<commit_message>
chore(01.2-05): populate Qdrant with 8 CCoP documents
- Ingested 8 CCoP documents via run_ingestion.py
- 87 chunks created (66 unique points in Qdrant)
- Collection: ccop_clauses_hybrid (1024-dim dense + BM25 sparse)
- Verified with 3 retrieval queries: all return relevant results

Co-Authored-By: Claude Opus 4.6 <noreply@anthropic.com>
</commit_message>
<xml_diff>
--- a/report/term1-end/MDAIE-AETher-FineTuning-LLM-CCoP-Sagar-1010736-20251219.pptx
+++ b/report/term1-end/MDAIE-AETher-FineTuning-LLM-CCoP-Sagar-1010736-20251219.pptx
@@ -5,7 +5,7 @@
     <p:sldMasterId id="2147483648" r:id="rId1"/>
   </p:sldMasterIdLst>
   <p:notesMasterIdLst>
-    <p:notesMasterId r:id="rId18"/>
+    <p:notesMasterId r:id="rId19"/>
   </p:notesMasterIdLst>
   <p:sldIdLst>
     <p:sldId id="288" r:id="rId2"/>
@@ -24,6 +24,7 @@
     <p:sldId id="268" r:id="rId15"/>
     <p:sldId id="263" r:id="rId16"/>
     <p:sldId id="289" r:id="rId17"/>
+    <p:sldId id="291" r:id="rId18"/>
   </p:sldIdLst>
   <p:sldSz cx="12192000" cy="6858000"/>
   <p:notesSz cx="6858000" cy="9144000"/>
@@ -220,7 +221,7 @@
           <a:p>
             <a:fld id="{87111E0E-CD2E-F04C-BE18-C841F5800BC7}" type="datetimeFigureOut">
               <a:rPr lang="en-US" smtClean="0"/>
-              <a:t>12/18/25</a:t>
+              <a:t>12/19/25</a:t>
             </a:fld>
             <a:endParaRPr lang="en-US"/>
           </a:p>
@@ -1135,6 +1136,114 @@
 </p:notes>
 </file>
 
+<file path=ppt/notesSlides/notesSlide15.xml><?xml version="1.0" encoding="utf-8"?>
+<p:notes xmlns:a="http://schemas.openxmlformats.org/drawingml/2006/main" xmlns:r="http://schemas.openxmlformats.org/officeDocument/2006/relationships" xmlns:p="http://schemas.openxmlformats.org/presentationml/2006/main">
+  <p:cSld>
+    <p:spTree>
+      <p:nvGrpSpPr>
+        <p:cNvPr id="1" name="">
+          <a:extLst>
+            <a:ext uri="{FF2B5EF4-FFF2-40B4-BE49-F238E27FC236}">
+              <a16:creationId xmlns:a16="http://schemas.microsoft.com/office/drawing/2014/main" id="{D1604728-F1EA-47F8-D648-1E940ADA09D1}"/>
+            </a:ext>
+          </a:extLst>
+        </p:cNvPr>
+        <p:cNvGrpSpPr/>
+        <p:nvPr/>
+      </p:nvGrpSpPr>
+      <p:grpSpPr>
+        <a:xfrm>
+          <a:off x="0" y="0"/>
+          <a:ext cx="0" cy="0"/>
+          <a:chOff x="0" y="0"/>
+          <a:chExt cx="0" cy="0"/>
+        </a:xfrm>
+      </p:grpSpPr>
+      <p:sp>
+        <p:nvSpPr>
+          <p:cNvPr id="2" name="Slide Image Placeholder 1">
+            <a:extLst>
+              <a:ext uri="{FF2B5EF4-FFF2-40B4-BE49-F238E27FC236}">
+                <a16:creationId xmlns:a16="http://schemas.microsoft.com/office/drawing/2014/main" id="{8EA59DC4-9CBF-BA73-CBA6-649EEB158958}"/>
+              </a:ext>
+            </a:extLst>
+          </p:cNvPr>
+          <p:cNvSpPr>
+            <a:spLocks noGrp="1" noRot="1" noChangeAspect="1"/>
+          </p:cNvSpPr>
+          <p:nvPr>
+            <p:ph type="sldImg"/>
+          </p:nvPr>
+        </p:nvSpPr>
+        <p:spPr/>
+      </p:sp>
+      <p:sp>
+        <p:nvSpPr>
+          <p:cNvPr id="3" name="Notes Placeholder 2">
+            <a:extLst>
+              <a:ext uri="{FF2B5EF4-FFF2-40B4-BE49-F238E27FC236}">
+                <a16:creationId xmlns:a16="http://schemas.microsoft.com/office/drawing/2014/main" id="{3DD798E0-80CF-0B7E-624C-02DEF00997F3}"/>
+              </a:ext>
+            </a:extLst>
+          </p:cNvPr>
+          <p:cNvSpPr>
+            <a:spLocks noGrp="1"/>
+          </p:cNvSpPr>
+          <p:nvPr>
+            <p:ph type="body" idx="1"/>
+          </p:nvPr>
+        </p:nvSpPr>
+        <p:spPr/>
+        <p:txBody>
+          <a:bodyPr/>
+          <a:lstStyle/>
+          <a:p>
+            <a:endParaRPr lang="en-US" dirty="0"/>
+          </a:p>
+        </p:txBody>
+      </p:sp>
+      <p:sp>
+        <p:nvSpPr>
+          <p:cNvPr id="4" name="Slide Number Placeholder 3">
+            <a:extLst>
+              <a:ext uri="{FF2B5EF4-FFF2-40B4-BE49-F238E27FC236}">
+                <a16:creationId xmlns:a16="http://schemas.microsoft.com/office/drawing/2014/main" id="{38BC0F24-1C47-3F1A-BB41-7AEC1D00CB38}"/>
+              </a:ext>
+            </a:extLst>
+          </p:cNvPr>
+          <p:cNvSpPr>
+            <a:spLocks noGrp="1"/>
+          </p:cNvSpPr>
+          <p:nvPr>
+            <p:ph type="sldNum" sz="quarter" idx="10"/>
+          </p:nvPr>
+        </p:nvSpPr>
+        <p:spPr/>
+        <p:txBody>
+          <a:bodyPr/>
+          <a:lstStyle/>
+          <a:p>
+            <a:fld id="{F7021451-1387-4CA6-816F-3879F97B5CBC}" type="slidenum">
+              <a:rPr lang="en-US"/>
+              <a:t>17</a:t>
+            </a:fld>
+            <a:endParaRPr lang="en-US"/>
+          </a:p>
+        </p:txBody>
+      </p:sp>
+    </p:spTree>
+    <p:extLst>
+      <p:ext uri="{BB962C8B-B14F-4D97-AF65-F5344CB8AC3E}">
+        <p14:creationId xmlns:p14="http://schemas.microsoft.com/office/powerpoint/2010/main" val="1390602641"/>
+      </p:ext>
+    </p:extLst>
+  </p:cSld>
+  <p:clrMapOvr>
+    <a:masterClrMapping/>
+  </p:clrMapOvr>
+</p:notes>
+</file>
+
 <file path=ppt/notesSlides/notesSlide2.xml><?xml version="1.0" encoding="utf-8"?>
 <p:notes xmlns:a="http://schemas.openxmlformats.org/drawingml/2006/main" xmlns:r="http://schemas.openxmlformats.org/officeDocument/2006/relationships" xmlns:p="http://schemas.openxmlformats.org/presentationml/2006/main">
   <p:cSld>
@@ -2013,7 +2122,7 @@
           <a:p>
             <a:fld id="{CE03B901-46DF-4543-A52F-025BAD1B5CD4}" type="datetimeFigureOut">
               <a:rPr lang="en-US" smtClean="0"/>
-              <a:t>12/18/25</a:t>
+              <a:t>12/19/25</a:t>
             </a:fld>
             <a:endParaRPr lang="en-US"/>
           </a:p>
@@ -2283,7 +2392,7 @@
           <a:p>
             <a:fld id="{CE03B901-46DF-4543-A52F-025BAD1B5CD4}" type="datetimeFigureOut">
               <a:rPr lang="en-US" smtClean="0"/>
-              <a:t>12/18/25</a:t>
+              <a:t>12/19/25</a:t>
             </a:fld>
             <a:endParaRPr lang="en-US"/>
           </a:p>
@@ -2654,7 +2763,7 @@
           <a:p>
             <a:fld id="{CE03B901-46DF-4543-A52F-025BAD1B5CD4}" type="datetimeFigureOut">
               <a:rPr lang="en-US" smtClean="0"/>
-              <a:t>12/18/25</a:t>
+              <a:t>12/19/25</a:t>
             </a:fld>
             <a:endParaRPr lang="en-US"/>
           </a:p>
@@ -2930,7 +3039,7 @@
           <a:p>
             <a:fld id="{CE03B901-46DF-4543-A52F-025BAD1B5CD4}" type="datetimeFigureOut">
               <a:rPr lang="en-US" smtClean="0"/>
-              <a:t>12/18/25</a:t>
+              <a:t>12/19/25</a:t>
             </a:fld>
             <a:endParaRPr lang="en-US"/>
           </a:p>
@@ -3405,7 +3514,7 @@
           <a:p>
             <a:fld id="{CE03B901-46DF-4543-A52F-025BAD1B5CD4}" type="datetimeFigureOut">
               <a:rPr lang="en-US" smtClean="0"/>
-              <a:t>12/18/25</a:t>
+              <a:t>12/19/25</a:t>
             </a:fld>
             <a:endParaRPr lang="en-US"/>
           </a:p>
@@ -3547,7 +3656,7 @@
           <a:p>
             <a:fld id="{CE03B901-46DF-4543-A52F-025BAD1B5CD4}" type="datetimeFigureOut">
               <a:rPr lang="en-US" smtClean="0"/>
-              <a:t>12/18/25</a:t>
+              <a:t>12/19/25</a:t>
             </a:fld>
             <a:endParaRPr lang="en-US"/>
           </a:p>
@@ -3660,7 +3769,7 @@
           <a:p>
             <a:fld id="{CE03B901-46DF-4543-A52F-025BAD1B5CD4}" type="datetimeFigureOut">
               <a:rPr lang="en-US" smtClean="0"/>
-              <a:t>12/18/25</a:t>
+              <a:t>12/19/25</a:t>
             </a:fld>
             <a:endParaRPr lang="en-US"/>
           </a:p>
@@ -3973,7 +4082,7 @@
           <a:p>
             <a:fld id="{CE03B901-46DF-4543-A52F-025BAD1B5CD4}" type="datetimeFigureOut">
               <a:rPr lang="en-US" smtClean="0"/>
-              <a:t>12/18/25</a:t>
+              <a:t>12/19/25</a:t>
             </a:fld>
             <a:endParaRPr lang="en-US"/>
           </a:p>
@@ -4262,7 +4371,7 @@
           <a:p>
             <a:fld id="{CE03B901-46DF-4543-A52F-025BAD1B5CD4}" type="datetimeFigureOut">
               <a:rPr lang="en-US" smtClean="0"/>
-              <a:t>12/18/25</a:t>
+              <a:t>12/19/25</a:t>
             </a:fld>
             <a:endParaRPr lang="en-US"/>
           </a:p>
@@ -4462,7 +4571,7 @@
           <a:p>
             <a:fld id="{CE03B901-46DF-4543-A52F-025BAD1B5CD4}" type="datetimeFigureOut">
               <a:rPr lang="en-US" smtClean="0"/>
-              <a:t>12/18/25</a:t>
+              <a:t>12/19/25</a:t>
             </a:fld>
             <a:endParaRPr lang="en-US"/>
           </a:p>
@@ -4705,7 +4814,7 @@
           <a:p>
             <a:fld id="{CE03B901-46DF-4543-A52F-025BAD1B5CD4}" type="datetimeFigureOut">
               <a:rPr lang="en-US" smtClean="0"/>
-              <a:t>12/18/25</a:t>
+              <a:t>12/19/25</a:t>
             </a:fld>
             <a:endParaRPr lang="en-US"/>
           </a:p>
@@ -5454,7 +5563,7 @@
                 <a:latin typeface="Kailasa" panose="02000500000000020004" pitchFamily="2" charset="0"/>
                 <a:cs typeface="Kailasa" panose="02000500000000020004" pitchFamily="2" charset="0"/>
               </a:rPr>
-              <a:t>MDAI-E Studio Term 1 Report</a:t>
+              <a:t>MDAI-E Studio Term 1 Report | SUTD</a:t>
             </a:r>
           </a:p>
           <a:p>
@@ -8458,7 +8567,7 @@
               </a:lnSpc>
             </a:pPr>
             <a:r>
-              <a:rPr lang="en-US" sz="900" dirty="0">
+              <a:rPr lang="en-US" sz="1100" i="1" dirty="0" err="1">
                 <a:solidFill>
                   <a:srgbClr val="64748B"/>
                 </a:solidFill>
@@ -8466,12 +8575,116 @@
                 <a:ea typeface="Source Sans Pro" panose="020B0503030403020204" pitchFamily="34" charset="0"/>
                 <a:cs typeface="Arial" pitchFamily="34" charset="-120"/>
               </a:rPr>
-              <a:t>Hybrid approach: automated metrics + LLM-as-Judge + human-in-the-loop validation by domain experts</a:t>
-            </a:r>
-            <a:endParaRPr lang="en-US" sz="900" dirty="0">
-              <a:latin typeface="Source Sans Pro" panose="020B0503030403020204" pitchFamily="34" charset="0"/>
-              <a:ea typeface="Source Sans Pro" panose="020B0503030403020204" pitchFamily="34" charset="0"/>
-            </a:endParaRPr>
+              <a:t>LalaEval</a:t>
+            </a:r>
+            <a:r>
+              <a:rPr lang="en-US" sz="1100" i="1" dirty="0">
+                <a:solidFill>
+                  <a:srgbClr val="64748B"/>
+                </a:solidFill>
+                <a:latin typeface="Source Sans Pro" panose="020B0503030403020204" pitchFamily="34" charset="0"/>
+                <a:ea typeface="Source Sans Pro" panose="020B0503030403020204" pitchFamily="34" charset="0"/>
+                <a:cs typeface="Arial" pitchFamily="34" charset="-120"/>
+              </a:rPr>
+              <a:t>: A Holistic Human Evaluation Framework for Domain-Specific Large Language Models  </a:t>
+            </a:r>
+            <a:r>
+              <a:rPr lang="en-US" sz="1100" i="1" dirty="0">
+                <a:solidFill>
+                  <a:srgbClr val="64748B"/>
+                </a:solidFill>
+                <a:latin typeface="Source Sans Pro" panose="020B0503030403020204" pitchFamily="34" charset="0"/>
+                <a:ea typeface="Source Sans Pro" panose="020B0503030403020204" pitchFamily="34" charset="0"/>
+                <a:cs typeface="Arial" pitchFamily="34" charset="-120"/>
+                <a:hlinkClick r:id="rId6"/>
+              </a:rPr>
+              <a:t>https://arxiv.org/abs/2408.13338</a:t>
+            </a:r>
+            <a:endParaRPr lang="en-US" sz="1100" i="1" dirty="0">
+              <a:solidFill>
+                <a:srgbClr val="64748B"/>
+              </a:solidFill>
+              <a:latin typeface="Source Sans Pro" panose="020B0503030403020204" pitchFamily="34" charset="0"/>
+              <a:ea typeface="Source Sans Pro" panose="020B0503030403020204" pitchFamily="34" charset="0"/>
+              <a:cs typeface="Arial" pitchFamily="34" charset="-120"/>
+            </a:endParaRPr>
+          </a:p>
+          <a:p>
+            <a:pPr>
+              <a:lnSpc>
+                <a:spcPts val="1260"/>
+              </a:lnSpc>
+            </a:pPr>
+            <a:r>
+              <a:rPr lang="en-US" sz="1100" i="1" dirty="0">
+                <a:solidFill>
+                  <a:srgbClr val="64748B"/>
+                </a:solidFill>
+                <a:latin typeface="Source Sans Pro" panose="020B0503030403020204" pitchFamily="34" charset="0"/>
+                <a:ea typeface="Source Sans Pro" panose="020B0503030403020204" pitchFamily="34" charset="0"/>
+                <a:cs typeface="Arial" pitchFamily="34" charset="-120"/>
+              </a:rPr>
+              <a:t> </a:t>
+            </a:r>
+          </a:p>
+          <a:p>
+            <a:pPr>
+              <a:lnSpc>
+                <a:spcPts val="1260"/>
+              </a:lnSpc>
+            </a:pPr>
+            <a:r>
+              <a:rPr lang="en-US" sz="1100" i="1" dirty="0">
+                <a:solidFill>
+                  <a:srgbClr val="64748B"/>
+                </a:solidFill>
+                <a:latin typeface="Source Sans Pro" panose="020B0503030403020204" pitchFamily="34" charset="0"/>
+                <a:ea typeface="Source Sans Pro" panose="020B0503030403020204" pitchFamily="34" charset="0"/>
+                <a:cs typeface="Arial" pitchFamily="34" charset="-120"/>
+              </a:rPr>
+              <a:t> </a:t>
+            </a:r>
+            <a:endParaRPr lang="en-US" sz="1100" i="1" dirty="0">
+              <a:latin typeface="Source Sans Pro" panose="020B0503030403020204" pitchFamily="34" charset="0"/>
+              <a:ea typeface="Source Sans Pro" panose="020B0503030403020204" pitchFamily="34" charset="0"/>
+            </a:endParaRPr>
+          </a:p>
+        </p:txBody>
+      </p:sp>
+      <p:sp>
+        <p:nvSpPr>
+          <p:cNvPr id="3" name="TextBox 2">
+            <a:extLst>
+              <a:ext uri="{FF2B5EF4-FFF2-40B4-BE49-F238E27FC236}">
+                <a16:creationId xmlns:a16="http://schemas.microsoft.com/office/drawing/2014/main" id="{69E3A16F-81B3-5EB0-001F-5A57F0D99E66}"/>
+              </a:ext>
+            </a:extLst>
+          </p:cNvPr>
+          <p:cNvSpPr txBox="1"/>
+          <p:nvPr/>
+        </p:nvSpPr>
+        <p:spPr>
+          <a:xfrm>
+            <a:off x="11776719" y="6400800"/>
+            <a:ext cx="304892" cy="369332"/>
+          </a:xfrm>
+          <a:prstGeom prst="rect">
+            <a:avLst/>
+          </a:prstGeom>
+          <a:noFill/>
+        </p:spPr>
+        <p:txBody>
+          <a:bodyPr wrap="none" rtlCol="0">
+            <a:spAutoFit/>
+          </a:bodyPr>
+          <a:lstStyle/>
+          <a:p>
+            <a:r>
+              <a:rPr lang="en-US" dirty="0">
+                <a:latin typeface="Tenorite" pitchFamily="2" charset="0"/>
+              </a:rPr>
+              <a:t>8</a:t>
+            </a:r>
           </a:p>
         </p:txBody>
       </p:sp>
@@ -11990,6 +12203,43 @@
           </a:p>
         </p:txBody>
       </p:sp>
+      <p:sp>
+        <p:nvSpPr>
+          <p:cNvPr id="9" name="TextBox 8">
+            <a:extLst>
+              <a:ext uri="{FF2B5EF4-FFF2-40B4-BE49-F238E27FC236}">
+                <a16:creationId xmlns:a16="http://schemas.microsoft.com/office/drawing/2014/main" id="{8518A797-F06F-A2A8-996C-F11629FCE7C7}"/>
+              </a:ext>
+            </a:extLst>
+          </p:cNvPr>
+          <p:cNvSpPr txBox="1"/>
+          <p:nvPr/>
+        </p:nvSpPr>
+        <p:spPr>
+          <a:xfrm>
+            <a:off x="11776719" y="6400800"/>
+            <a:ext cx="304892" cy="369332"/>
+          </a:xfrm>
+          <a:prstGeom prst="rect">
+            <a:avLst/>
+          </a:prstGeom>
+          <a:noFill/>
+        </p:spPr>
+        <p:txBody>
+          <a:bodyPr wrap="none" rtlCol="0">
+            <a:spAutoFit/>
+          </a:bodyPr>
+          <a:lstStyle/>
+          <a:p>
+            <a:r>
+              <a:rPr lang="en-US" dirty="0">
+                <a:latin typeface="Tenorite" pitchFamily="2" charset="0"/>
+              </a:rPr>
+              <a:t>9</a:t>
+            </a:r>
+          </a:p>
+        </p:txBody>
+      </p:sp>
     </p:spTree>
   </p:cSld>
   <p:clrMapOvr>
@@ -14512,6 +14762,43 @@
           </a:p>
         </p:txBody>
       </p:sp>
+      <p:sp>
+        <p:nvSpPr>
+          <p:cNvPr id="63" name="TextBox 62">
+            <a:extLst>
+              <a:ext uri="{FF2B5EF4-FFF2-40B4-BE49-F238E27FC236}">
+                <a16:creationId xmlns:a16="http://schemas.microsoft.com/office/drawing/2014/main" id="{791EC8DB-8EE0-A3FB-1B65-171A8FEAE752}"/>
+              </a:ext>
+            </a:extLst>
+          </p:cNvPr>
+          <p:cNvSpPr txBox="1"/>
+          <p:nvPr/>
+        </p:nvSpPr>
+        <p:spPr>
+          <a:xfrm>
+            <a:off x="11776719" y="6400800"/>
+            <a:ext cx="425116" cy="369332"/>
+          </a:xfrm>
+          <a:prstGeom prst="rect">
+            <a:avLst/>
+          </a:prstGeom>
+          <a:noFill/>
+        </p:spPr>
+        <p:txBody>
+          <a:bodyPr wrap="none" rtlCol="0">
+            <a:spAutoFit/>
+          </a:bodyPr>
+          <a:lstStyle/>
+          <a:p>
+            <a:r>
+              <a:rPr lang="en-US" dirty="0">
+                <a:latin typeface="Tenorite" pitchFamily="2" charset="0"/>
+              </a:rPr>
+              <a:t>10</a:t>
+            </a:r>
+          </a:p>
+        </p:txBody>
+      </p:sp>
     </p:spTree>
   </p:cSld>
   <p:clrMapOvr>
@@ -17511,6 +17798,43 @@
           </a:p>
         </p:txBody>
       </p:sp>
+      <p:sp>
+        <p:nvSpPr>
+          <p:cNvPr id="30" name="TextBox 29">
+            <a:extLst>
+              <a:ext uri="{FF2B5EF4-FFF2-40B4-BE49-F238E27FC236}">
+                <a16:creationId xmlns:a16="http://schemas.microsoft.com/office/drawing/2014/main" id="{9E1476A3-5015-94C3-F7CA-E011DA18CF42}"/>
+              </a:ext>
+            </a:extLst>
+          </p:cNvPr>
+          <p:cNvSpPr txBox="1"/>
+          <p:nvPr/>
+        </p:nvSpPr>
+        <p:spPr>
+          <a:xfrm>
+            <a:off x="11776719" y="6400800"/>
+            <a:ext cx="425116" cy="369332"/>
+          </a:xfrm>
+          <a:prstGeom prst="rect">
+            <a:avLst/>
+          </a:prstGeom>
+          <a:noFill/>
+        </p:spPr>
+        <p:txBody>
+          <a:bodyPr wrap="none" rtlCol="0">
+            <a:spAutoFit/>
+          </a:bodyPr>
+          <a:lstStyle/>
+          <a:p>
+            <a:r>
+              <a:rPr lang="en-US" dirty="0">
+                <a:latin typeface="Tenorite" pitchFamily="2" charset="0"/>
+              </a:rPr>
+              <a:t>11</a:t>
+            </a:r>
+          </a:p>
+        </p:txBody>
+      </p:sp>
     </p:spTree>
   </p:cSld>
   <p:clrMapOvr>
@@ -17723,7 +18047,7 @@
                 <a:ea typeface="Tenorite" pitchFamily="34" charset="-122"/>
                 <a:cs typeface="Tenorite" pitchFamily="34" charset="-120"/>
               </a:rPr>
-              <a:t>48%</a:t>
+              <a:t>49%</a:t>
             </a:r>
             <a:endParaRPr lang="en-US" sz="2000" dirty="0"/>
           </a:p>
@@ -19224,6 +19548,43 @@
                 <a:cs typeface="Source Sans Pro" pitchFamily="34" charset="-120"/>
               </a:rPr>
               <a:t>60%</a:t>
+            </a:r>
+          </a:p>
+        </p:txBody>
+      </p:sp>
+      <p:sp>
+        <p:nvSpPr>
+          <p:cNvPr id="2" name="TextBox 1">
+            <a:extLst>
+              <a:ext uri="{FF2B5EF4-FFF2-40B4-BE49-F238E27FC236}">
+                <a16:creationId xmlns:a16="http://schemas.microsoft.com/office/drawing/2014/main" id="{7A1C32E1-A6B3-C8F0-025D-282D4E58DF6C}"/>
+              </a:ext>
+            </a:extLst>
+          </p:cNvPr>
+          <p:cNvSpPr txBox="1"/>
+          <p:nvPr/>
+        </p:nvSpPr>
+        <p:spPr>
+          <a:xfrm>
+            <a:off x="11776719" y="6400800"/>
+            <a:ext cx="425116" cy="369332"/>
+          </a:xfrm>
+          <a:prstGeom prst="rect">
+            <a:avLst/>
+          </a:prstGeom>
+          <a:noFill/>
+        </p:spPr>
+        <p:txBody>
+          <a:bodyPr wrap="none" rtlCol="0">
+            <a:spAutoFit/>
+          </a:bodyPr>
+          <a:lstStyle/>
+          <a:p>
+            <a:r>
+              <a:rPr lang="en-US" dirty="0">
+                <a:latin typeface="Tenorite" pitchFamily="2" charset="0"/>
+              </a:rPr>
+              <a:t>12</a:t>
             </a:r>
           </a:p>
         </p:txBody>
@@ -20957,6 +21318,43 @@
           <a:lstStyle/>
           <a:p>
             <a:endParaRPr lang="en-US" sz="2400"/>
+          </a:p>
+        </p:txBody>
+      </p:sp>
+      <p:sp>
+        <p:nvSpPr>
+          <p:cNvPr id="44" name="TextBox 43">
+            <a:extLst>
+              <a:ext uri="{FF2B5EF4-FFF2-40B4-BE49-F238E27FC236}">
+                <a16:creationId xmlns:a16="http://schemas.microsoft.com/office/drawing/2014/main" id="{16550116-6199-3069-6D0C-BBC20745F09C}"/>
+              </a:ext>
+            </a:extLst>
+          </p:cNvPr>
+          <p:cNvSpPr txBox="1"/>
+          <p:nvPr/>
+        </p:nvSpPr>
+        <p:spPr>
+          <a:xfrm>
+            <a:off x="11776719" y="6400800"/>
+            <a:ext cx="425116" cy="369332"/>
+          </a:xfrm>
+          <a:prstGeom prst="rect">
+            <a:avLst/>
+          </a:prstGeom>
+          <a:noFill/>
+        </p:spPr>
+        <p:txBody>
+          <a:bodyPr wrap="none" rtlCol="0">
+            <a:spAutoFit/>
+          </a:bodyPr>
+          <a:lstStyle/>
+          <a:p>
+            <a:r>
+              <a:rPr lang="en-US" dirty="0">
+                <a:latin typeface="Tenorite" pitchFamily="2" charset="0"/>
+              </a:rPr>
+              <a:t>13</a:t>
+            </a:r>
           </a:p>
         </p:txBody>
       </p:sp>
@@ -21187,6 +21585,1021 @@
 </p:sld>
 </file>
 
+<file path=ppt/slides/slide17.xml><?xml version="1.0" encoding="utf-8"?>
+<p:sld xmlns:a="http://schemas.openxmlformats.org/drawingml/2006/main" xmlns:r="http://schemas.openxmlformats.org/officeDocument/2006/relationships" xmlns:p="http://schemas.openxmlformats.org/presentationml/2006/main">
+  <p:cSld>
+    <p:spTree>
+      <p:nvGrpSpPr>
+        <p:cNvPr id="1" name="">
+          <a:extLst>
+            <a:ext uri="{FF2B5EF4-FFF2-40B4-BE49-F238E27FC236}">
+              <a16:creationId xmlns:a16="http://schemas.microsoft.com/office/drawing/2014/main" id="{5E121CBE-4E23-C4FF-6E07-FEE0D2302E64}"/>
+            </a:ext>
+          </a:extLst>
+        </p:cNvPr>
+        <p:cNvGrpSpPr/>
+        <p:nvPr/>
+      </p:nvGrpSpPr>
+      <p:grpSpPr>
+        <a:xfrm>
+          <a:off x="0" y="0"/>
+          <a:ext cx="0" cy="0"/>
+          <a:chOff x="0" y="0"/>
+          <a:chExt cx="0" cy="0"/>
+        </a:xfrm>
+      </p:grpSpPr>
+      <p:sp>
+        <p:nvSpPr>
+          <p:cNvPr id="2" name="Text 0">
+            <a:extLst>
+              <a:ext uri="{FF2B5EF4-FFF2-40B4-BE49-F238E27FC236}">
+                <a16:creationId xmlns:a16="http://schemas.microsoft.com/office/drawing/2014/main" id="{0FA81496-FB12-611C-711C-B4F1771ED688}"/>
+              </a:ext>
+            </a:extLst>
+          </p:cNvPr>
+          <p:cNvSpPr/>
+          <p:nvPr/>
+        </p:nvSpPr>
+        <p:spPr>
+          <a:xfrm>
+            <a:off x="459152" y="304800"/>
+            <a:ext cx="11326448" cy="406400"/>
+          </a:xfrm>
+          <a:prstGeom prst="rect">
+            <a:avLst/>
+          </a:prstGeom>
+          <a:noFill/>
+          <a:ln/>
+        </p:spPr>
+        <p:txBody>
+          <a:bodyPr wrap="square" lIns="0" tIns="0" rIns="0" bIns="0" rtlCol="0" anchor="t"/>
+          <a:lstStyle/>
+          <a:p>
+            <a:pPr>
+              <a:lnSpc>
+                <a:spcPts val="3200"/>
+              </a:lnSpc>
+              <a:spcAft>
+                <a:spcPts val="400"/>
+              </a:spcAft>
+            </a:pPr>
+            <a:r>
+              <a:rPr lang="en-US" sz="4400" dirty="0">
+                <a:solidFill>
+                  <a:srgbClr val="374151"/>
+                </a:solidFill>
+                <a:latin typeface="Tenorite" pitchFamily="34" charset="0"/>
+                <a:ea typeface="Tenorite" pitchFamily="34" charset="-122"/>
+                <a:cs typeface="Tenorite" pitchFamily="34" charset="-120"/>
+              </a:rPr>
+              <a:t>Example: Fine-tuning vs RAG vs Hybrid </a:t>
+            </a:r>
+            <a:endParaRPr lang="en-US" sz="4400" dirty="0"/>
+          </a:p>
+        </p:txBody>
+      </p:sp>
+      <p:sp>
+        <p:nvSpPr>
+          <p:cNvPr id="3" name="Text 1">
+            <a:extLst>
+              <a:ext uri="{FF2B5EF4-FFF2-40B4-BE49-F238E27FC236}">
+                <a16:creationId xmlns:a16="http://schemas.microsoft.com/office/drawing/2014/main" id="{33BA8949-E2FD-6A6F-8C76-CB10E503DE55}"/>
+              </a:ext>
+            </a:extLst>
+          </p:cNvPr>
+          <p:cNvSpPr/>
+          <p:nvPr/>
+        </p:nvSpPr>
+        <p:spPr>
+          <a:xfrm>
+            <a:off x="459152" y="762000"/>
+            <a:ext cx="11606784" cy="230981"/>
+          </a:xfrm>
+          <a:prstGeom prst="rect">
+            <a:avLst/>
+          </a:prstGeom>
+          <a:noFill/>
+          <a:ln/>
+        </p:spPr>
+        <p:txBody>
+          <a:bodyPr wrap="square" lIns="0" tIns="0" rIns="0" bIns="0" rtlCol="0" anchor="t"/>
+          <a:lstStyle/>
+          <a:p>
+            <a:pPr>
+              <a:lnSpc>
+                <a:spcPts val="1820"/>
+              </a:lnSpc>
+            </a:pPr>
+            <a:r>
+              <a:rPr lang="en-US" sz="1200" dirty="0">
+                <a:solidFill>
+                  <a:srgbClr val="64748B"/>
+                </a:solidFill>
+                <a:latin typeface="Tenorite" pitchFamily="2" charset="0"/>
+                <a:ea typeface="Arial" pitchFamily="34" charset="-122"/>
+                <a:cs typeface="Arial" pitchFamily="34" charset="-120"/>
+              </a:rPr>
+              <a:t>CCoP Example</a:t>
+            </a:r>
+            <a:endParaRPr lang="en-US" sz="1200" dirty="0">
+              <a:latin typeface="Tenorite" pitchFamily="2" charset="0"/>
+            </a:endParaRPr>
+          </a:p>
+        </p:txBody>
+      </p:sp>
+      <p:sp>
+        <p:nvSpPr>
+          <p:cNvPr id="43" name="Shape 36">
+            <a:extLst>
+              <a:ext uri="{FF2B5EF4-FFF2-40B4-BE49-F238E27FC236}">
+                <a16:creationId xmlns:a16="http://schemas.microsoft.com/office/drawing/2014/main" id="{163ADCBB-812B-C095-9D43-54D54EE2E0DD}"/>
+              </a:ext>
+            </a:extLst>
+          </p:cNvPr>
+          <p:cNvSpPr/>
+          <p:nvPr/>
+        </p:nvSpPr>
+        <p:spPr>
+          <a:xfrm>
+            <a:off x="406400" y="6285309"/>
+            <a:ext cx="11379200" cy="0"/>
+          </a:xfrm>
+          <a:prstGeom prst="line">
+            <a:avLst/>
+          </a:prstGeom>
+          <a:noFill/>
+          <a:ln w="9525">
+            <a:solidFill>
+              <a:srgbClr val="E2E8F0"/>
+            </a:solidFill>
+            <a:prstDash val="solid"/>
+          </a:ln>
+        </p:spPr>
+        <p:txBody>
+          <a:bodyPr/>
+          <a:lstStyle/>
+          <a:p>
+            <a:endParaRPr lang="en-US" sz="2400"/>
+          </a:p>
+        </p:txBody>
+      </p:sp>
+      <p:graphicFrame>
+        <p:nvGraphicFramePr>
+          <p:cNvPr id="45" name="Table 44">
+            <a:extLst>
+              <a:ext uri="{FF2B5EF4-FFF2-40B4-BE49-F238E27FC236}">
+                <a16:creationId xmlns:a16="http://schemas.microsoft.com/office/drawing/2014/main" id="{67A2F961-F659-B923-5CCD-F117939C466A}"/>
+              </a:ext>
+            </a:extLst>
+          </p:cNvPr>
+          <p:cNvGraphicFramePr>
+            <a:graphicFrameLocks noGrp="1"/>
+          </p:cNvGraphicFramePr>
+          <p:nvPr>
+            <p:extLst>
+              <p:ext uri="{D42A27DB-BD31-4B8C-83A1-F6EECF244321}">
+                <p14:modId xmlns:p14="http://schemas.microsoft.com/office/powerpoint/2010/main" val="3989030910"/>
+              </p:ext>
+            </p:extLst>
+          </p:nvPr>
+        </p:nvGraphicFramePr>
+        <p:xfrm>
+          <a:off x="1245218" y="2363487"/>
+          <a:ext cx="9701560" cy="3235446"/>
+        </p:xfrm>
+        <a:graphic>
+          <a:graphicData uri="http://schemas.openxmlformats.org/drawingml/2006/table">
+            <a:tbl>
+              <a:tblPr>
+                <a:tableStyleId>{793D81CF-94F2-401A-BA57-92F5A7B2D0C5}</a:tableStyleId>
+              </a:tblPr>
+              <a:tblGrid>
+                <a:gridCol w="1260775">
+                  <a:extLst>
+                    <a:ext uri="{9D8B030D-6E8A-4147-A177-3AD203B41FA5}">
+                      <a16:colId xmlns:a16="http://schemas.microsoft.com/office/drawing/2014/main" val="3242004673"/>
+                    </a:ext>
+                  </a:extLst>
+                </a:gridCol>
+                <a:gridCol w="2371967">
+                  <a:extLst>
+                    <a:ext uri="{9D8B030D-6E8A-4147-A177-3AD203B41FA5}">
+                      <a16:colId xmlns:a16="http://schemas.microsoft.com/office/drawing/2014/main" val="975146724"/>
+                    </a:ext>
+                  </a:extLst>
+                </a:gridCol>
+                <a:gridCol w="2425391">
+                  <a:extLst>
+                    <a:ext uri="{9D8B030D-6E8A-4147-A177-3AD203B41FA5}">
+                      <a16:colId xmlns:a16="http://schemas.microsoft.com/office/drawing/2014/main" val="4217747071"/>
+                    </a:ext>
+                  </a:extLst>
+                </a:gridCol>
+                <a:gridCol w="3643427">
+                  <a:extLst>
+                    <a:ext uri="{9D8B030D-6E8A-4147-A177-3AD203B41FA5}">
+                      <a16:colId xmlns:a16="http://schemas.microsoft.com/office/drawing/2014/main" val="3678044613"/>
+                    </a:ext>
+                  </a:extLst>
+                </a:gridCol>
+              </a:tblGrid>
+              <a:tr h="482272">
+                <a:tc>
+                  <a:txBody>
+                    <a:bodyPr/>
+                    <a:lstStyle/>
+                    <a:p>
+                      <a:pPr>
+                        <a:lnSpc>
+                          <a:spcPct val="115000"/>
+                        </a:lnSpc>
+                        <a:buNone/>
+                      </a:pPr>
+                      <a:r>
+                        <a:rPr lang="en-GB" sz="1100" b="1" dirty="0">
+                          <a:effectLst/>
+                          <a:latin typeface="Source Sans Pro" panose="020B0503030403020204" pitchFamily="34" charset="0"/>
+                          <a:ea typeface="Source Sans Pro" panose="020B0503030403020204" pitchFamily="34" charset="0"/>
+                        </a:rPr>
+                        <a:t> </a:t>
+                      </a:r>
+                      <a:endParaRPr lang="en-SG" sz="1100" dirty="0">
+                        <a:effectLst/>
+                        <a:latin typeface="Source Sans Pro" panose="020B0503030403020204" pitchFamily="34" charset="0"/>
+                        <a:ea typeface="Source Sans Pro" panose="020B0503030403020204" pitchFamily="34" charset="0"/>
+                      </a:endParaRPr>
+                    </a:p>
+                  </a:txBody>
+                  <a:tcPr marL="63500" marR="63500" marT="63500" marB="63500">
+                    <a:lnL w="12700" cap="flat" cmpd="sng" algn="ctr">
+                      <a:solidFill>
+                        <a:schemeClr val="tx1"/>
+                      </a:solidFill>
+                      <a:prstDash val="solid"/>
+                      <a:round/>
+                      <a:headEnd type="none" w="med" len="med"/>
+                      <a:tailEnd type="none" w="med" len="med"/>
+                    </a:lnL>
+                    <a:lnR w="12700" cap="flat" cmpd="sng" algn="ctr">
+                      <a:solidFill>
+                        <a:schemeClr val="tx1"/>
+                      </a:solidFill>
+                      <a:prstDash val="solid"/>
+                      <a:round/>
+                      <a:headEnd type="none" w="med" len="med"/>
+                      <a:tailEnd type="none" w="med" len="med"/>
+                    </a:lnR>
+                    <a:lnT w="12700" cap="flat" cmpd="sng" algn="ctr">
+                      <a:solidFill>
+                        <a:schemeClr val="tx1"/>
+                      </a:solidFill>
+                      <a:prstDash val="solid"/>
+                      <a:round/>
+                      <a:headEnd type="none" w="med" len="med"/>
+                      <a:tailEnd type="none" w="med" len="med"/>
+                    </a:lnT>
+                    <a:lnB w="12700" cap="flat" cmpd="sng" algn="ctr">
+                      <a:solidFill>
+                        <a:schemeClr val="tx1"/>
+                      </a:solidFill>
+                      <a:prstDash val="solid"/>
+                      <a:round/>
+                      <a:headEnd type="none" w="med" len="med"/>
+                      <a:tailEnd type="none" w="med" len="med"/>
+                    </a:lnB>
+                  </a:tcPr>
+                </a:tc>
+                <a:tc>
+                  <a:txBody>
+                    <a:bodyPr/>
+                    <a:lstStyle/>
+                    <a:p>
+                      <a:pPr algn="ctr">
+                        <a:lnSpc>
+                          <a:spcPct val="115000"/>
+                        </a:lnSpc>
+                        <a:buNone/>
+                      </a:pPr>
+                      <a:r>
+                        <a:rPr lang="en-GB" sz="1100" b="1" dirty="0">
+                          <a:solidFill>
+                            <a:schemeClr val="bg2">
+                              <a:lumMod val="50000"/>
+                            </a:schemeClr>
+                          </a:solidFill>
+                          <a:effectLst/>
+                          <a:latin typeface="Source Sans Pro" panose="020B0503030403020204" pitchFamily="34" charset="0"/>
+                          <a:ea typeface="Source Sans Pro" panose="020B0503030403020204" pitchFamily="34" charset="0"/>
+                        </a:rPr>
+                        <a:t>Fine-Tuning Only</a:t>
+                      </a:r>
+                      <a:endParaRPr lang="en-SG" sz="1100" dirty="0">
+                        <a:solidFill>
+                          <a:schemeClr val="bg2">
+                            <a:lumMod val="50000"/>
+                          </a:schemeClr>
+                        </a:solidFill>
+                        <a:effectLst/>
+                        <a:latin typeface="Source Sans Pro" panose="020B0503030403020204" pitchFamily="34" charset="0"/>
+                        <a:ea typeface="Source Sans Pro" panose="020B0503030403020204" pitchFamily="34" charset="0"/>
+                      </a:endParaRPr>
+                    </a:p>
+                  </a:txBody>
+                  <a:tcPr marL="63500" marR="63500" marT="63500" marB="63500" anchor="ctr">
+                    <a:lnL w="12700" cap="flat" cmpd="sng" algn="ctr">
+                      <a:solidFill>
+                        <a:schemeClr val="tx1"/>
+                      </a:solidFill>
+                      <a:prstDash val="solid"/>
+                      <a:round/>
+                      <a:headEnd type="none" w="med" len="med"/>
+                      <a:tailEnd type="none" w="med" len="med"/>
+                    </a:lnL>
+                    <a:lnR w="12700" cap="flat" cmpd="sng" algn="ctr">
+                      <a:solidFill>
+                        <a:schemeClr val="tx1"/>
+                      </a:solidFill>
+                      <a:prstDash val="solid"/>
+                      <a:round/>
+                      <a:headEnd type="none" w="med" len="med"/>
+                      <a:tailEnd type="none" w="med" len="med"/>
+                    </a:lnR>
+                    <a:lnT w="12700" cap="flat" cmpd="sng" algn="ctr">
+                      <a:solidFill>
+                        <a:schemeClr val="tx1"/>
+                      </a:solidFill>
+                      <a:prstDash val="solid"/>
+                      <a:round/>
+                      <a:headEnd type="none" w="med" len="med"/>
+                      <a:tailEnd type="none" w="med" len="med"/>
+                    </a:lnT>
+                    <a:lnB w="12700" cap="flat" cmpd="sng" algn="ctr">
+                      <a:solidFill>
+                        <a:schemeClr val="tx1"/>
+                      </a:solidFill>
+                      <a:prstDash val="solid"/>
+                      <a:round/>
+                      <a:headEnd type="none" w="med" len="med"/>
+                      <a:tailEnd type="none" w="med" len="med"/>
+                    </a:lnB>
+                  </a:tcPr>
+                </a:tc>
+                <a:tc>
+                  <a:txBody>
+                    <a:bodyPr/>
+                    <a:lstStyle/>
+                    <a:p>
+                      <a:pPr algn="ctr">
+                        <a:lnSpc>
+                          <a:spcPct val="115000"/>
+                        </a:lnSpc>
+                        <a:buNone/>
+                      </a:pPr>
+                      <a:r>
+                        <a:rPr lang="en-GB" sz="1100" b="1">
+                          <a:solidFill>
+                            <a:schemeClr val="bg2">
+                              <a:lumMod val="50000"/>
+                            </a:schemeClr>
+                          </a:solidFill>
+                          <a:effectLst/>
+                          <a:latin typeface="Source Sans Pro" panose="020B0503030403020204" pitchFamily="34" charset="0"/>
+                          <a:ea typeface="Source Sans Pro" panose="020B0503030403020204" pitchFamily="34" charset="0"/>
+                        </a:rPr>
+                        <a:t>RAG Only</a:t>
+                      </a:r>
+                      <a:endParaRPr lang="en-SG" sz="1100">
+                        <a:solidFill>
+                          <a:schemeClr val="bg2">
+                            <a:lumMod val="50000"/>
+                          </a:schemeClr>
+                        </a:solidFill>
+                        <a:effectLst/>
+                        <a:latin typeface="Source Sans Pro" panose="020B0503030403020204" pitchFamily="34" charset="0"/>
+                        <a:ea typeface="Source Sans Pro" panose="020B0503030403020204" pitchFamily="34" charset="0"/>
+                      </a:endParaRPr>
+                    </a:p>
+                  </a:txBody>
+                  <a:tcPr marL="63500" marR="63500" marT="63500" marB="63500" anchor="ctr">
+                    <a:lnL w="12700" cap="flat" cmpd="sng" algn="ctr">
+                      <a:solidFill>
+                        <a:schemeClr val="tx1"/>
+                      </a:solidFill>
+                      <a:prstDash val="solid"/>
+                      <a:round/>
+                      <a:headEnd type="none" w="med" len="med"/>
+                      <a:tailEnd type="none" w="med" len="med"/>
+                    </a:lnL>
+                    <a:lnR w="12700" cap="flat" cmpd="sng" algn="ctr">
+                      <a:solidFill>
+                        <a:schemeClr val="tx1"/>
+                      </a:solidFill>
+                      <a:prstDash val="solid"/>
+                      <a:round/>
+                      <a:headEnd type="none" w="med" len="med"/>
+                      <a:tailEnd type="none" w="med" len="med"/>
+                    </a:lnR>
+                    <a:lnT w="12700" cap="flat" cmpd="sng" algn="ctr">
+                      <a:solidFill>
+                        <a:schemeClr val="tx1"/>
+                      </a:solidFill>
+                      <a:prstDash val="solid"/>
+                      <a:round/>
+                      <a:headEnd type="none" w="med" len="med"/>
+                      <a:tailEnd type="none" w="med" len="med"/>
+                    </a:lnT>
+                    <a:lnB w="12700" cap="flat" cmpd="sng" algn="ctr">
+                      <a:solidFill>
+                        <a:schemeClr val="tx1"/>
+                      </a:solidFill>
+                      <a:prstDash val="solid"/>
+                      <a:round/>
+                      <a:headEnd type="none" w="med" len="med"/>
+                      <a:tailEnd type="none" w="med" len="med"/>
+                    </a:lnB>
+                  </a:tcPr>
+                </a:tc>
+                <a:tc>
+                  <a:txBody>
+                    <a:bodyPr/>
+                    <a:lstStyle/>
+                    <a:p>
+                      <a:pPr algn="ctr">
+                        <a:lnSpc>
+                          <a:spcPct val="115000"/>
+                        </a:lnSpc>
+                        <a:buNone/>
+                      </a:pPr>
+                      <a:r>
+                        <a:rPr lang="en-GB" sz="1100" b="1" dirty="0">
+                          <a:solidFill>
+                            <a:schemeClr val="bg2">
+                              <a:lumMod val="50000"/>
+                            </a:schemeClr>
+                          </a:solidFill>
+                          <a:effectLst/>
+                          <a:latin typeface="Source Sans Pro" panose="020B0503030403020204" pitchFamily="34" charset="0"/>
+                          <a:ea typeface="Source Sans Pro" panose="020B0503030403020204" pitchFamily="34" charset="0"/>
+                        </a:rPr>
+                        <a:t>Hybrid (Fine-Tuning + RAG)</a:t>
+                      </a:r>
+                      <a:endParaRPr lang="en-SG" sz="1100" dirty="0">
+                        <a:solidFill>
+                          <a:schemeClr val="bg2">
+                            <a:lumMod val="50000"/>
+                          </a:schemeClr>
+                        </a:solidFill>
+                        <a:effectLst/>
+                        <a:latin typeface="Source Sans Pro" panose="020B0503030403020204" pitchFamily="34" charset="0"/>
+                        <a:ea typeface="Source Sans Pro" panose="020B0503030403020204" pitchFamily="34" charset="0"/>
+                      </a:endParaRPr>
+                    </a:p>
+                  </a:txBody>
+                  <a:tcPr marL="63500" marR="63500" marT="63500" marB="63500" anchor="ctr">
+                    <a:lnL w="12700" cap="flat" cmpd="sng" algn="ctr">
+                      <a:solidFill>
+                        <a:schemeClr val="tx1"/>
+                      </a:solidFill>
+                      <a:prstDash val="solid"/>
+                      <a:round/>
+                      <a:headEnd type="none" w="med" len="med"/>
+                      <a:tailEnd type="none" w="med" len="med"/>
+                    </a:lnL>
+                    <a:lnR w="12700" cap="flat" cmpd="sng" algn="ctr">
+                      <a:solidFill>
+                        <a:schemeClr val="tx1"/>
+                      </a:solidFill>
+                      <a:prstDash val="solid"/>
+                      <a:round/>
+                      <a:headEnd type="none" w="med" len="med"/>
+                      <a:tailEnd type="none" w="med" len="med"/>
+                    </a:lnR>
+                    <a:lnT w="12700" cap="flat" cmpd="sng" algn="ctr">
+                      <a:solidFill>
+                        <a:schemeClr val="tx1"/>
+                      </a:solidFill>
+                      <a:prstDash val="solid"/>
+                      <a:round/>
+                      <a:headEnd type="none" w="med" len="med"/>
+                      <a:tailEnd type="none" w="med" len="med"/>
+                    </a:lnT>
+                    <a:lnB w="12700" cap="flat" cmpd="sng" algn="ctr">
+                      <a:solidFill>
+                        <a:schemeClr val="tx1"/>
+                      </a:solidFill>
+                      <a:prstDash val="solid"/>
+                      <a:round/>
+                      <a:headEnd type="none" w="med" len="med"/>
+                      <a:tailEnd type="none" w="med" len="med"/>
+                    </a:lnB>
+                  </a:tcPr>
+                </a:tc>
+                <a:extLst>
+                  <a:ext uri="{0D108BD9-81ED-4DB2-BD59-A6C34878D82A}">
+                    <a16:rowId xmlns:a16="http://schemas.microsoft.com/office/drawing/2014/main" val="2754829168"/>
+                  </a:ext>
+                </a:extLst>
+              </a:tr>
+              <a:tr h="2753174">
+                <a:tc>
+                  <a:txBody>
+                    <a:bodyPr/>
+                    <a:lstStyle/>
+                    <a:p>
+                      <a:pPr>
+                        <a:lnSpc>
+                          <a:spcPct val="150000"/>
+                        </a:lnSpc>
+                        <a:spcBef>
+                          <a:spcPts val="1200"/>
+                        </a:spcBef>
+                        <a:spcAft>
+                          <a:spcPts val="1200"/>
+                        </a:spcAft>
+                        <a:buNone/>
+                      </a:pPr>
+                      <a:r>
+                        <a:rPr lang="en-GB" sz="1100" b="1" dirty="0">
+                          <a:solidFill>
+                            <a:srgbClr val="000000"/>
+                          </a:solidFill>
+                          <a:effectLst/>
+                          <a:latin typeface="Source Sans Pro" panose="020B0503030403020204" pitchFamily="34" charset="0"/>
+                          <a:ea typeface="Source Sans Pro" panose="020B0503030403020204" pitchFamily="34" charset="0"/>
+                        </a:rPr>
+                        <a:t>Sample LLM Response</a:t>
+                      </a:r>
+                      <a:endParaRPr lang="en-SG" sz="1100" dirty="0">
+                        <a:effectLst/>
+                        <a:latin typeface="Source Sans Pro" panose="020B0503030403020204" pitchFamily="34" charset="0"/>
+                        <a:ea typeface="Source Sans Pro" panose="020B0503030403020204" pitchFamily="34" charset="0"/>
+                      </a:endParaRPr>
+                    </a:p>
+                  </a:txBody>
+                  <a:tcPr marL="63500" marR="63500" marT="63500" marB="63500">
+                    <a:lnL w="12700" cap="flat" cmpd="sng" algn="ctr">
+                      <a:solidFill>
+                        <a:schemeClr val="tx1"/>
+                      </a:solidFill>
+                      <a:prstDash val="solid"/>
+                      <a:round/>
+                      <a:headEnd type="none" w="med" len="med"/>
+                      <a:tailEnd type="none" w="med" len="med"/>
+                    </a:lnL>
+                    <a:lnR w="12700" cap="flat" cmpd="sng" algn="ctr">
+                      <a:solidFill>
+                        <a:schemeClr val="tx1"/>
+                      </a:solidFill>
+                      <a:prstDash val="solid"/>
+                      <a:round/>
+                      <a:headEnd type="none" w="med" len="med"/>
+                      <a:tailEnd type="none" w="med" len="med"/>
+                    </a:lnR>
+                    <a:lnT w="12700" cap="flat" cmpd="sng" algn="ctr">
+                      <a:solidFill>
+                        <a:schemeClr val="tx1"/>
+                      </a:solidFill>
+                      <a:prstDash val="solid"/>
+                      <a:round/>
+                      <a:headEnd type="none" w="med" len="med"/>
+                      <a:tailEnd type="none" w="med" len="med"/>
+                    </a:lnT>
+                    <a:lnB w="12700" cap="flat" cmpd="sng" algn="ctr">
+                      <a:solidFill>
+                        <a:schemeClr val="tx1"/>
+                      </a:solidFill>
+                      <a:prstDash val="solid"/>
+                      <a:round/>
+                      <a:headEnd type="none" w="med" len="med"/>
+                      <a:tailEnd type="none" w="med" len="med"/>
+                    </a:lnB>
+                  </a:tcPr>
+                </a:tc>
+                <a:tc>
+                  <a:txBody>
+                    <a:bodyPr/>
+                    <a:lstStyle/>
+                    <a:p>
+                      <a:pPr>
+                        <a:lnSpc>
+                          <a:spcPct val="150000"/>
+                        </a:lnSpc>
+                        <a:spcBef>
+                          <a:spcPts val="1200"/>
+                        </a:spcBef>
+                        <a:spcAft>
+                          <a:spcPts val="1200"/>
+                        </a:spcAft>
+                        <a:buNone/>
+                      </a:pPr>
+                      <a:r>
+                        <a:rPr lang="en-GB" sz="1200" dirty="0">
+                          <a:solidFill>
+                            <a:srgbClr val="000000"/>
+                          </a:solidFill>
+                          <a:effectLst/>
+                          <a:latin typeface="Source Sans Pro" panose="020B0503030403020204" pitchFamily="34" charset="0"/>
+                          <a:ea typeface="Source Sans Pro" panose="020B0503030403020204" pitchFamily="34" charset="0"/>
+                        </a:rPr>
+                        <a:t>“Using shared administrative accounts for vendor access introduces accountability and monitoring risks. Such a setup is generally considered non-compliant with good access control practices and may require stronger controls to meet </a:t>
+                      </a:r>
+                      <a:r>
+                        <a:rPr lang="en-GB" sz="1200" dirty="0" err="1">
+                          <a:solidFill>
+                            <a:srgbClr val="000000"/>
+                          </a:solidFill>
+                          <a:effectLst/>
+                          <a:latin typeface="Source Sans Pro" panose="020B0503030403020204" pitchFamily="34" charset="0"/>
+                          <a:ea typeface="Source Sans Pro" panose="020B0503030403020204" pitchFamily="34" charset="0"/>
+                        </a:rPr>
+                        <a:t>CCoP</a:t>
+                      </a:r>
+                      <a:r>
+                        <a:rPr lang="en-GB" sz="1200" dirty="0">
+                          <a:solidFill>
+                            <a:srgbClr val="000000"/>
+                          </a:solidFill>
+                          <a:effectLst/>
+                          <a:latin typeface="Source Sans Pro" panose="020B0503030403020204" pitchFamily="34" charset="0"/>
+                          <a:ea typeface="Source Sans Pro" panose="020B0503030403020204" pitchFamily="34" charset="0"/>
+                        </a:rPr>
+                        <a:t> expectations.”</a:t>
+                      </a:r>
+                      <a:endParaRPr lang="en-SG" sz="1200" dirty="0">
+                        <a:effectLst/>
+                        <a:latin typeface="Source Sans Pro" panose="020B0503030403020204" pitchFamily="34" charset="0"/>
+                        <a:ea typeface="Source Sans Pro" panose="020B0503030403020204" pitchFamily="34" charset="0"/>
+                      </a:endParaRPr>
+                    </a:p>
+                  </a:txBody>
+                  <a:tcPr marL="63500" marR="63500" marT="63500" marB="63500">
+                    <a:lnL w="12700" cap="flat" cmpd="sng" algn="ctr">
+                      <a:solidFill>
+                        <a:schemeClr val="tx1"/>
+                      </a:solidFill>
+                      <a:prstDash val="solid"/>
+                      <a:round/>
+                      <a:headEnd type="none" w="med" len="med"/>
+                      <a:tailEnd type="none" w="med" len="med"/>
+                    </a:lnL>
+                    <a:lnR w="12700" cap="flat" cmpd="sng" algn="ctr">
+                      <a:solidFill>
+                        <a:schemeClr val="tx1"/>
+                      </a:solidFill>
+                      <a:prstDash val="solid"/>
+                      <a:round/>
+                      <a:headEnd type="none" w="med" len="med"/>
+                      <a:tailEnd type="none" w="med" len="med"/>
+                    </a:lnR>
+                    <a:lnT w="12700" cap="flat" cmpd="sng" algn="ctr">
+                      <a:solidFill>
+                        <a:schemeClr val="tx1"/>
+                      </a:solidFill>
+                      <a:prstDash val="solid"/>
+                      <a:round/>
+                      <a:headEnd type="none" w="med" len="med"/>
+                      <a:tailEnd type="none" w="med" len="med"/>
+                    </a:lnT>
+                    <a:lnB w="12700" cap="flat" cmpd="sng" algn="ctr">
+                      <a:solidFill>
+                        <a:schemeClr val="tx1"/>
+                      </a:solidFill>
+                      <a:prstDash val="solid"/>
+                      <a:round/>
+                      <a:headEnd type="none" w="med" len="med"/>
+                      <a:tailEnd type="none" w="med" len="med"/>
+                    </a:lnB>
+                  </a:tcPr>
+                </a:tc>
+                <a:tc>
+                  <a:txBody>
+                    <a:bodyPr/>
+                    <a:lstStyle/>
+                    <a:p>
+                      <a:pPr>
+                        <a:lnSpc>
+                          <a:spcPct val="150000"/>
+                        </a:lnSpc>
+                        <a:spcBef>
+                          <a:spcPts val="1200"/>
+                        </a:spcBef>
+                        <a:spcAft>
+                          <a:spcPts val="1200"/>
+                        </a:spcAft>
+                        <a:buNone/>
+                      </a:pPr>
+                      <a:r>
+                        <a:rPr lang="en-GB" sz="1200" dirty="0">
+                          <a:solidFill>
+                            <a:srgbClr val="000000"/>
+                          </a:solidFill>
+                          <a:effectLst/>
+                          <a:latin typeface="Source Sans Pro" panose="020B0503030403020204" pitchFamily="34" charset="0"/>
+                          <a:ea typeface="Source Sans Pro" panose="020B0503030403020204" pitchFamily="34" charset="0"/>
+                        </a:rPr>
+                        <a:t>“</a:t>
+                      </a:r>
+                      <a:r>
+                        <a:rPr lang="en-GB" sz="1200" dirty="0" err="1">
+                          <a:solidFill>
+                            <a:srgbClr val="000000"/>
+                          </a:solidFill>
+                          <a:effectLst/>
+                          <a:latin typeface="Source Sans Pro" panose="020B0503030403020204" pitchFamily="34" charset="0"/>
+                          <a:ea typeface="Source Sans Pro" panose="020B0503030403020204" pitchFamily="34" charset="0"/>
+                        </a:rPr>
+                        <a:t>CCoP</a:t>
+                      </a:r>
+                      <a:r>
+                        <a:rPr lang="en-GB" sz="1200" dirty="0">
+                          <a:solidFill>
+                            <a:srgbClr val="000000"/>
+                          </a:solidFill>
+                          <a:effectLst/>
+                          <a:latin typeface="Source Sans Pro" panose="020B0503030403020204" pitchFamily="34" charset="0"/>
+                          <a:ea typeface="Source Sans Pro" panose="020B0503030403020204" pitchFamily="34" charset="0"/>
+                        </a:rPr>
+                        <a:t> 2.0 states that access to critical systems shall be restricted to authorised personnel and that third-party access must be authorised, monitored, and reviewed. Privileged activities shall also be logged and reviewed regularly.”</a:t>
+                      </a:r>
+                      <a:endParaRPr lang="en-SG" sz="1200" dirty="0">
+                        <a:effectLst/>
+                        <a:latin typeface="Source Sans Pro" panose="020B0503030403020204" pitchFamily="34" charset="0"/>
+                        <a:ea typeface="Source Sans Pro" panose="020B0503030403020204" pitchFamily="34" charset="0"/>
+                      </a:endParaRPr>
+                    </a:p>
+                  </a:txBody>
+                  <a:tcPr marL="63500" marR="63500" marT="63500" marB="63500">
+                    <a:lnL w="12700" cap="flat" cmpd="sng" algn="ctr">
+                      <a:solidFill>
+                        <a:schemeClr val="tx1"/>
+                      </a:solidFill>
+                      <a:prstDash val="solid"/>
+                      <a:round/>
+                      <a:headEnd type="none" w="med" len="med"/>
+                      <a:tailEnd type="none" w="med" len="med"/>
+                    </a:lnL>
+                    <a:lnR w="12700" cap="flat" cmpd="sng" algn="ctr">
+                      <a:solidFill>
+                        <a:schemeClr val="tx1"/>
+                      </a:solidFill>
+                      <a:prstDash val="solid"/>
+                      <a:round/>
+                      <a:headEnd type="none" w="med" len="med"/>
+                      <a:tailEnd type="none" w="med" len="med"/>
+                    </a:lnR>
+                    <a:lnT w="12700" cap="flat" cmpd="sng" algn="ctr">
+                      <a:solidFill>
+                        <a:schemeClr val="tx1"/>
+                      </a:solidFill>
+                      <a:prstDash val="solid"/>
+                      <a:round/>
+                      <a:headEnd type="none" w="med" len="med"/>
+                      <a:tailEnd type="none" w="med" len="med"/>
+                    </a:lnT>
+                    <a:lnB w="12700" cap="flat" cmpd="sng" algn="ctr">
+                      <a:solidFill>
+                        <a:schemeClr val="tx1"/>
+                      </a:solidFill>
+                      <a:prstDash val="solid"/>
+                      <a:round/>
+                      <a:headEnd type="none" w="med" len="med"/>
+                      <a:tailEnd type="none" w="med" len="med"/>
+                    </a:lnB>
+                  </a:tcPr>
+                </a:tc>
+                <a:tc>
+                  <a:txBody>
+                    <a:bodyPr/>
+                    <a:lstStyle/>
+                    <a:p>
+                      <a:pPr>
+                        <a:lnSpc>
+                          <a:spcPct val="150000"/>
+                        </a:lnSpc>
+                        <a:spcBef>
+                          <a:spcPts val="1200"/>
+                        </a:spcBef>
+                        <a:spcAft>
+                          <a:spcPts val="1200"/>
+                        </a:spcAft>
+                        <a:buNone/>
+                      </a:pPr>
+                      <a:r>
+                        <a:rPr lang="en-GB" sz="1200" dirty="0">
+                          <a:solidFill>
+                            <a:srgbClr val="000000"/>
+                          </a:solidFill>
+                          <a:effectLst/>
+                          <a:latin typeface="Source Sans Pro" panose="020B0503030403020204" pitchFamily="34" charset="0"/>
+                          <a:ea typeface="Source Sans Pro" panose="020B0503030403020204" pitchFamily="34" charset="0"/>
+                        </a:rPr>
+                        <a:t>“According to </a:t>
+                      </a:r>
+                      <a:r>
+                        <a:rPr lang="en-GB" sz="1200" dirty="0" err="1">
+                          <a:solidFill>
+                            <a:srgbClr val="000000"/>
+                          </a:solidFill>
+                          <a:effectLst/>
+                          <a:latin typeface="Source Sans Pro" panose="020B0503030403020204" pitchFamily="34" charset="0"/>
+                          <a:ea typeface="Source Sans Pro" panose="020B0503030403020204" pitchFamily="34" charset="0"/>
+                        </a:rPr>
+                        <a:t>CCoP</a:t>
+                      </a:r>
+                      <a:r>
+                        <a:rPr lang="en-GB" sz="1200" dirty="0">
+                          <a:solidFill>
+                            <a:srgbClr val="000000"/>
+                          </a:solidFill>
+                          <a:effectLst/>
+                          <a:latin typeface="Source Sans Pro" panose="020B0503030403020204" pitchFamily="34" charset="0"/>
+                          <a:ea typeface="Source Sans Pro" panose="020B0503030403020204" pitchFamily="34" charset="0"/>
+                        </a:rPr>
+                        <a:t> 2.0 clauses on access control and third-party access, vendor access to critical systems must be authorised, monitored, and individually accountable. The use of shared administrative accounts weakens accountability and is therefore likely non-compliant unless compensating controls are implemented, such as uniquely assigned vendor accounts, access logging, and periodic access reviews.”</a:t>
+                      </a:r>
+                      <a:endParaRPr lang="en-SG" sz="1200" dirty="0">
+                        <a:effectLst/>
+                        <a:latin typeface="Source Sans Pro" panose="020B0503030403020204" pitchFamily="34" charset="0"/>
+                        <a:ea typeface="Source Sans Pro" panose="020B0503030403020204" pitchFamily="34" charset="0"/>
+                      </a:endParaRPr>
+                    </a:p>
+                  </a:txBody>
+                  <a:tcPr marL="63500" marR="63500" marT="63500" marB="63500">
+                    <a:lnL w="12700" cap="flat" cmpd="sng" algn="ctr">
+                      <a:solidFill>
+                        <a:schemeClr val="tx1"/>
+                      </a:solidFill>
+                      <a:prstDash val="solid"/>
+                      <a:round/>
+                      <a:headEnd type="none" w="med" len="med"/>
+                      <a:tailEnd type="none" w="med" len="med"/>
+                    </a:lnL>
+                    <a:lnR w="12700" cap="flat" cmpd="sng" algn="ctr">
+                      <a:solidFill>
+                        <a:schemeClr val="tx1"/>
+                      </a:solidFill>
+                      <a:prstDash val="solid"/>
+                      <a:round/>
+                      <a:headEnd type="none" w="med" len="med"/>
+                      <a:tailEnd type="none" w="med" len="med"/>
+                    </a:lnR>
+                    <a:lnT w="12700" cap="flat" cmpd="sng" algn="ctr">
+                      <a:solidFill>
+                        <a:schemeClr val="tx1"/>
+                      </a:solidFill>
+                      <a:prstDash val="solid"/>
+                      <a:round/>
+                      <a:headEnd type="none" w="med" len="med"/>
+                      <a:tailEnd type="none" w="med" len="med"/>
+                    </a:lnT>
+                    <a:lnB w="12700" cap="flat" cmpd="sng" algn="ctr">
+                      <a:solidFill>
+                        <a:schemeClr val="tx1"/>
+                      </a:solidFill>
+                      <a:prstDash val="solid"/>
+                      <a:round/>
+                      <a:headEnd type="none" w="med" len="med"/>
+                      <a:tailEnd type="none" w="med" len="med"/>
+                    </a:lnB>
+                  </a:tcPr>
+                </a:tc>
+                <a:extLst>
+                  <a:ext uri="{0D108BD9-81ED-4DB2-BD59-A6C34878D82A}">
+                    <a16:rowId xmlns:a16="http://schemas.microsoft.com/office/drawing/2014/main" val="2883825990"/>
+                  </a:ext>
+                </a:extLst>
+              </a:tr>
+            </a:tbl>
+          </a:graphicData>
+        </a:graphic>
+      </p:graphicFrame>
+      <p:sp>
+        <p:nvSpPr>
+          <p:cNvPr id="46" name="TextBox 45">
+            <a:extLst>
+              <a:ext uri="{FF2B5EF4-FFF2-40B4-BE49-F238E27FC236}">
+                <a16:creationId xmlns:a16="http://schemas.microsoft.com/office/drawing/2014/main" id="{DEF6E14B-7F05-373A-E0C4-FE02CE7D2018}"/>
+              </a:ext>
+            </a:extLst>
+          </p:cNvPr>
+          <p:cNvSpPr txBox="1"/>
+          <p:nvPr/>
+        </p:nvSpPr>
+        <p:spPr>
+          <a:xfrm>
+            <a:off x="11776719" y="6400800"/>
+            <a:ext cx="425116" cy="369332"/>
+          </a:xfrm>
+          <a:prstGeom prst="rect">
+            <a:avLst/>
+          </a:prstGeom>
+          <a:noFill/>
+        </p:spPr>
+        <p:txBody>
+          <a:bodyPr wrap="none" rtlCol="0">
+            <a:spAutoFit/>
+          </a:bodyPr>
+          <a:lstStyle/>
+          <a:p>
+            <a:r>
+              <a:rPr lang="en-US" dirty="0">
+                <a:latin typeface="Tenorite" pitchFamily="2" charset="0"/>
+              </a:rPr>
+              <a:t>14</a:t>
+            </a:r>
+          </a:p>
+        </p:txBody>
+      </p:sp>
+      <p:sp>
+        <p:nvSpPr>
+          <p:cNvPr id="47" name="TextBox 46">
+            <a:extLst>
+              <a:ext uri="{FF2B5EF4-FFF2-40B4-BE49-F238E27FC236}">
+                <a16:creationId xmlns:a16="http://schemas.microsoft.com/office/drawing/2014/main" id="{7C975432-42FF-5080-4814-3C0F30C1F896}"/>
+              </a:ext>
+            </a:extLst>
+          </p:cNvPr>
+          <p:cNvSpPr txBox="1"/>
+          <p:nvPr/>
+        </p:nvSpPr>
+        <p:spPr>
+          <a:xfrm>
+            <a:off x="1172276" y="1193936"/>
+            <a:ext cx="9847445" cy="1169551"/>
+          </a:xfrm>
+          <a:prstGeom prst="rect">
+            <a:avLst/>
+          </a:prstGeom>
+          <a:noFill/>
+        </p:spPr>
+        <p:txBody>
+          <a:bodyPr wrap="square" rtlCol="0">
+            <a:spAutoFit/>
+          </a:bodyPr>
+          <a:lstStyle/>
+          <a:p>
+            <a:r>
+              <a:rPr lang="en-GB" sz="1400" i="1" u="sng" dirty="0">
+                <a:latin typeface="Source Sans Pro" panose="020B0503030403020204" pitchFamily="34" charset="0"/>
+                <a:ea typeface="Source Sans Pro" panose="020B0503030403020204" pitchFamily="34" charset="0"/>
+              </a:rPr>
+              <a:t>Sample Question</a:t>
+            </a:r>
+          </a:p>
+          <a:p>
+            <a:endParaRPr lang="en-GB" sz="1400" i="1" u="sng" dirty="0">
+              <a:latin typeface="Source Sans Pro" panose="020B0503030403020204" pitchFamily="34" charset="0"/>
+              <a:ea typeface="Source Sans Pro" panose="020B0503030403020204" pitchFamily="34" charset="0"/>
+            </a:endParaRPr>
+          </a:p>
+          <a:p>
+            <a:r>
+              <a:rPr lang="en-GB" sz="1400" i="1" dirty="0">
+                <a:latin typeface="Source Sans Pro" panose="020B0503030403020204" pitchFamily="34" charset="0"/>
+                <a:ea typeface="Source Sans Pro" panose="020B0503030403020204" pitchFamily="34" charset="0"/>
+              </a:rPr>
+              <a:t>“Our organisation allows third-party vendors to remotely access CII production systems for maintenance using shared administrative accounts. Is this compliant with </a:t>
+            </a:r>
+            <a:r>
+              <a:rPr lang="en-GB" sz="1400" i="1" dirty="0" err="1">
+                <a:latin typeface="Source Sans Pro" panose="020B0503030403020204" pitchFamily="34" charset="0"/>
+                <a:ea typeface="Source Sans Pro" panose="020B0503030403020204" pitchFamily="34" charset="0"/>
+              </a:rPr>
+              <a:t>CCoP</a:t>
+            </a:r>
+            <a:r>
+              <a:rPr lang="en-GB" sz="1400" i="1" dirty="0">
+                <a:latin typeface="Source Sans Pro" panose="020B0503030403020204" pitchFamily="34" charset="0"/>
+                <a:ea typeface="Source Sans Pro" panose="020B0503030403020204" pitchFamily="34" charset="0"/>
+              </a:rPr>
+              <a:t> 2.0?”</a:t>
+            </a:r>
+            <a:endParaRPr lang="en-SG" sz="1400" dirty="0">
+              <a:latin typeface="Source Sans Pro" panose="020B0503030403020204" pitchFamily="34" charset="0"/>
+              <a:ea typeface="Source Sans Pro" panose="020B0503030403020204" pitchFamily="34" charset="0"/>
+            </a:endParaRPr>
+          </a:p>
+          <a:p>
+            <a:endParaRPr lang="en-US" sz="1400" dirty="0">
+              <a:latin typeface="Source Sans Pro" panose="020B0503030403020204" pitchFamily="34" charset="0"/>
+              <a:ea typeface="Source Sans Pro" panose="020B0503030403020204" pitchFamily="34" charset="0"/>
+            </a:endParaRPr>
+          </a:p>
+        </p:txBody>
+      </p:sp>
+    </p:spTree>
+    <p:extLst>
+      <p:ext uri="{BB962C8B-B14F-4D97-AF65-F5344CB8AC3E}">
+        <p14:creationId xmlns:p14="http://schemas.microsoft.com/office/powerpoint/2010/main" val="581014715"/>
+      </p:ext>
+    </p:extLst>
+  </p:cSld>
+  <p:clrMapOvr>
+    <a:masterClrMapping/>
+  </p:clrMapOvr>
+</p:sld>
+</file>
+
 <file path=ppt/slides/slide2.xml><?xml version="1.0" encoding="utf-8"?>
 <p:sld xmlns:a="http://schemas.openxmlformats.org/drawingml/2006/main" xmlns:r="http://schemas.openxmlformats.org/officeDocument/2006/relationships" xmlns:p="http://schemas.openxmlformats.org/presentationml/2006/main">
   <p:cSld>
@@ -26595,6 +28008,43 @@
           </a:p>
         </p:txBody>
       </p:sp>
+      <p:sp>
+        <p:nvSpPr>
+          <p:cNvPr id="3" name="TextBox 2">
+            <a:extLst>
+              <a:ext uri="{FF2B5EF4-FFF2-40B4-BE49-F238E27FC236}">
+                <a16:creationId xmlns:a16="http://schemas.microsoft.com/office/drawing/2014/main" id="{1D5757D3-BB3A-A644-CE21-97171EFC8734}"/>
+              </a:ext>
+            </a:extLst>
+          </p:cNvPr>
+          <p:cNvSpPr txBox="1"/>
+          <p:nvPr/>
+        </p:nvSpPr>
+        <p:spPr>
+          <a:xfrm>
+            <a:off x="11776719" y="6400800"/>
+            <a:ext cx="308098" cy="369332"/>
+          </a:xfrm>
+          <a:prstGeom prst="rect">
+            <a:avLst/>
+          </a:prstGeom>
+          <a:noFill/>
+        </p:spPr>
+        <p:txBody>
+          <a:bodyPr wrap="none" rtlCol="0">
+            <a:spAutoFit/>
+          </a:bodyPr>
+          <a:lstStyle/>
+          <a:p>
+            <a:r>
+              <a:rPr lang="en-US" dirty="0">
+                <a:latin typeface="Tenorite" pitchFamily="2" charset="0"/>
+              </a:rPr>
+              <a:t>1</a:t>
+            </a:r>
+          </a:p>
+        </p:txBody>
+      </p:sp>
     </p:spTree>
     <p:extLst>
       <p:ext uri="{BB962C8B-B14F-4D97-AF65-F5344CB8AC3E}">
@@ -29898,6 +31348,43 @@
           </a:p>
         </p:txBody>
       </p:sp>
+      <p:sp>
+        <p:nvSpPr>
+          <p:cNvPr id="2" name="TextBox 1">
+            <a:extLst>
+              <a:ext uri="{FF2B5EF4-FFF2-40B4-BE49-F238E27FC236}">
+                <a16:creationId xmlns:a16="http://schemas.microsoft.com/office/drawing/2014/main" id="{5F64149C-B503-2F7D-D9A3-1D6163D60E01}"/>
+              </a:ext>
+            </a:extLst>
+          </p:cNvPr>
+          <p:cNvSpPr txBox="1"/>
+          <p:nvPr/>
+        </p:nvSpPr>
+        <p:spPr>
+          <a:xfrm>
+            <a:off x="11776719" y="6400800"/>
+            <a:ext cx="304892" cy="369332"/>
+          </a:xfrm>
+          <a:prstGeom prst="rect">
+            <a:avLst/>
+          </a:prstGeom>
+          <a:noFill/>
+        </p:spPr>
+        <p:txBody>
+          <a:bodyPr wrap="none" rtlCol="0">
+            <a:spAutoFit/>
+          </a:bodyPr>
+          <a:lstStyle/>
+          <a:p>
+            <a:r>
+              <a:rPr lang="en-US" dirty="0">
+                <a:latin typeface="Tenorite" pitchFamily="2" charset="0"/>
+              </a:rPr>
+              <a:t>2</a:t>
+            </a:r>
+          </a:p>
+        </p:txBody>
+      </p:sp>
     </p:spTree>
   </p:cSld>
   <p:clrMapOvr>
@@ -31395,6 +32882,43 @@
           </a:p>
         </p:txBody>
       </p:sp>
+      <p:sp>
+        <p:nvSpPr>
+          <p:cNvPr id="39" name="TextBox 38">
+            <a:extLst>
+              <a:ext uri="{FF2B5EF4-FFF2-40B4-BE49-F238E27FC236}">
+                <a16:creationId xmlns:a16="http://schemas.microsoft.com/office/drawing/2014/main" id="{A35F50AC-A9F1-CA5F-1DC3-20A4D85D8DA9}"/>
+              </a:ext>
+            </a:extLst>
+          </p:cNvPr>
+          <p:cNvSpPr txBox="1"/>
+          <p:nvPr/>
+        </p:nvSpPr>
+        <p:spPr>
+          <a:xfrm>
+            <a:off x="11776719" y="6400800"/>
+            <a:ext cx="304892" cy="369332"/>
+          </a:xfrm>
+          <a:prstGeom prst="rect">
+            <a:avLst/>
+          </a:prstGeom>
+          <a:noFill/>
+        </p:spPr>
+        <p:txBody>
+          <a:bodyPr wrap="none" rtlCol="0">
+            <a:spAutoFit/>
+          </a:bodyPr>
+          <a:lstStyle/>
+          <a:p>
+            <a:r>
+              <a:rPr lang="en-US" dirty="0">
+                <a:latin typeface="Tenorite" pitchFamily="2" charset="0"/>
+              </a:rPr>
+              <a:t>3</a:t>
+            </a:r>
+          </a:p>
+        </p:txBody>
+      </p:sp>
     </p:spTree>
   </p:cSld>
   <p:clrMapOvr>
@@ -33334,6 +34858,43 @@
           </a:p>
         </p:txBody>
       </p:sp>
+      <p:sp>
+        <p:nvSpPr>
+          <p:cNvPr id="47" name="TextBox 46">
+            <a:extLst>
+              <a:ext uri="{FF2B5EF4-FFF2-40B4-BE49-F238E27FC236}">
+                <a16:creationId xmlns:a16="http://schemas.microsoft.com/office/drawing/2014/main" id="{734267AC-5AE6-4025-F4BD-2E4C9880717F}"/>
+              </a:ext>
+            </a:extLst>
+          </p:cNvPr>
+          <p:cNvSpPr txBox="1"/>
+          <p:nvPr/>
+        </p:nvSpPr>
+        <p:spPr>
+          <a:xfrm>
+            <a:off x="11776719" y="6400800"/>
+            <a:ext cx="304892" cy="369332"/>
+          </a:xfrm>
+          <a:prstGeom prst="rect">
+            <a:avLst/>
+          </a:prstGeom>
+          <a:noFill/>
+        </p:spPr>
+        <p:txBody>
+          <a:bodyPr wrap="none" rtlCol="0">
+            <a:spAutoFit/>
+          </a:bodyPr>
+          <a:lstStyle/>
+          <a:p>
+            <a:r>
+              <a:rPr lang="en-US" dirty="0">
+                <a:latin typeface="Tenorite" pitchFamily="2" charset="0"/>
+              </a:rPr>
+              <a:t>4</a:t>
+            </a:r>
+          </a:p>
+        </p:txBody>
+      </p:sp>
     </p:spTree>
   </p:cSld>
   <p:clrMapOvr>
@@ -33422,7 +34983,7 @@
         </p:nvSpPr>
         <p:spPr>
           <a:xfrm>
-            <a:off x="508000" y="1153518"/>
+            <a:off x="508000" y="814473"/>
             <a:ext cx="5461000" cy="4530725"/>
           </a:xfrm>
           <a:prstGeom prst="rect">
@@ -33456,7 +35017,7 @@
         </p:nvSpPr>
         <p:spPr>
           <a:xfrm>
-            <a:off x="736600" y="1364605"/>
+            <a:off x="736600" y="1025560"/>
             <a:ext cx="1573005" cy="431796"/>
           </a:xfrm>
           <a:prstGeom prst="roundRect">
@@ -33488,7 +35049,7 @@
         </p:nvSpPr>
         <p:spPr>
           <a:xfrm>
-            <a:off x="863600" y="1500676"/>
+            <a:off x="863600" y="1161631"/>
             <a:ext cx="1282394" cy="251819"/>
           </a:xfrm>
           <a:prstGeom prst="rect">
@@ -33532,7 +35093,7 @@
         </p:nvSpPr>
         <p:spPr>
           <a:xfrm>
-            <a:off x="2407131" y="1491311"/>
+            <a:off x="2407131" y="1152266"/>
             <a:ext cx="3732617" cy="377225"/>
           </a:xfrm>
           <a:prstGeom prst="rect">
@@ -33585,7 +35146,7 @@
         </p:nvSpPr>
         <p:spPr>
           <a:xfrm>
-            <a:off x="736600" y="1987276"/>
+            <a:off x="736600" y="1648231"/>
             <a:ext cx="5103876" cy="342900"/>
           </a:xfrm>
           <a:prstGeom prst="rect">
@@ -33629,7 +35190,7 @@
         </p:nvSpPr>
         <p:spPr>
           <a:xfrm>
-            <a:off x="736600" y="2791817"/>
+            <a:off x="736600" y="2452772"/>
             <a:ext cx="5003800" cy="985440"/>
           </a:xfrm>
           <a:prstGeom prst="roundRect">
@@ -33661,7 +35222,7 @@
         </p:nvSpPr>
         <p:spPr>
           <a:xfrm>
-            <a:off x="889001" y="2918818"/>
+            <a:off x="889001" y="2579773"/>
             <a:ext cx="4792980" cy="159940"/>
           </a:xfrm>
           <a:prstGeom prst="rect">
@@ -33708,7 +35269,7 @@
         </p:nvSpPr>
         <p:spPr>
           <a:xfrm>
-            <a:off x="889001" y="3142257"/>
+            <a:off x="889001" y="2803212"/>
             <a:ext cx="4792980" cy="152400"/>
           </a:xfrm>
           <a:prstGeom prst="rect">
@@ -33752,7 +35313,7 @@
         </p:nvSpPr>
         <p:spPr>
           <a:xfrm>
-            <a:off x="889001" y="3320057"/>
+            <a:off x="889001" y="2981012"/>
             <a:ext cx="4792980" cy="152400"/>
           </a:xfrm>
           <a:prstGeom prst="rect">
@@ -33799,7 +35360,7 @@
         </p:nvSpPr>
         <p:spPr>
           <a:xfrm>
-            <a:off x="889001" y="3497857"/>
+            <a:off x="889001" y="3158812"/>
             <a:ext cx="4792980" cy="152400"/>
           </a:xfrm>
           <a:prstGeom prst="rect">
@@ -33846,7 +35407,7 @@
         </p:nvSpPr>
         <p:spPr>
           <a:xfrm>
-            <a:off x="736600" y="4132857"/>
+            <a:off x="736600" y="3793812"/>
             <a:ext cx="5003800" cy="1322784"/>
           </a:xfrm>
           <a:prstGeom prst="roundRect">
@@ -33882,7 +35443,7 @@
         </p:nvSpPr>
         <p:spPr>
           <a:xfrm>
-            <a:off x="901700" y="4272558"/>
+            <a:off x="901700" y="3933513"/>
             <a:ext cx="4767072" cy="142081"/>
           </a:xfrm>
           <a:prstGeom prst="rect">
@@ -33929,7 +35490,7 @@
         </p:nvSpPr>
         <p:spPr>
           <a:xfrm>
-            <a:off x="901700" y="4490840"/>
+            <a:off x="901700" y="4151795"/>
             <a:ext cx="4767072" cy="142081"/>
           </a:xfrm>
           <a:prstGeom prst="rect">
@@ -33976,7 +35537,7 @@
         </p:nvSpPr>
         <p:spPr>
           <a:xfrm>
-            <a:off x="901700" y="4709120"/>
+            <a:off x="901700" y="4370075"/>
             <a:ext cx="4673600" cy="606821"/>
           </a:xfrm>
           <a:prstGeom prst="roundRect">
@@ -34008,7 +35569,7 @@
         </p:nvSpPr>
         <p:spPr>
           <a:xfrm>
-            <a:off x="1003300" y="4785321"/>
+            <a:off x="1003300" y="4446276"/>
             <a:ext cx="4559808" cy="142081"/>
           </a:xfrm>
           <a:prstGeom prst="rect">
@@ -34052,7 +35613,7 @@
         </p:nvSpPr>
         <p:spPr>
           <a:xfrm>
-            <a:off x="1003300" y="4965502"/>
+            <a:off x="1003300" y="4626457"/>
             <a:ext cx="4559808" cy="124420"/>
           </a:xfrm>
           <a:prstGeom prst="rect">
@@ -34099,7 +35660,7 @@
         </p:nvSpPr>
         <p:spPr>
           <a:xfrm>
-            <a:off x="1003300" y="5115322"/>
+            <a:off x="1003300" y="4776277"/>
             <a:ext cx="4559808" cy="124420"/>
           </a:xfrm>
           <a:prstGeom prst="rect">
@@ -34146,7 +35707,7 @@
         </p:nvSpPr>
         <p:spPr>
           <a:xfrm>
-            <a:off x="6223000" y="1153518"/>
+            <a:off x="6223000" y="814473"/>
             <a:ext cx="5461000" cy="4530725"/>
           </a:xfrm>
           <a:prstGeom prst="rect">
@@ -34180,7 +35741,7 @@
         </p:nvSpPr>
         <p:spPr>
           <a:xfrm>
-            <a:off x="6393749" y="1334048"/>
+            <a:off x="6393749" y="995003"/>
             <a:ext cx="1346154" cy="417510"/>
           </a:xfrm>
           <a:prstGeom prst="roundRect">
@@ -34212,7 +35773,7 @@
         </p:nvSpPr>
         <p:spPr>
           <a:xfrm>
-            <a:off x="6574544" y="1493608"/>
+            <a:off x="6574544" y="1154563"/>
             <a:ext cx="1024835" cy="241301"/>
           </a:xfrm>
           <a:prstGeom prst="rect">
@@ -34309,7 +35870,7 @@
         </p:nvSpPr>
         <p:spPr>
           <a:xfrm>
-            <a:off x="6451600" y="1987276"/>
+            <a:off x="6451600" y="1648231"/>
             <a:ext cx="5103876" cy="342900"/>
           </a:xfrm>
           <a:prstGeom prst="rect">
@@ -34353,7 +35914,7 @@
         </p:nvSpPr>
         <p:spPr>
           <a:xfrm>
-            <a:off x="6451600" y="2791817"/>
+            <a:off x="6451600" y="2452772"/>
             <a:ext cx="5003800" cy="985440"/>
           </a:xfrm>
           <a:prstGeom prst="roundRect">
@@ -34385,7 +35946,7 @@
         </p:nvSpPr>
         <p:spPr>
           <a:xfrm>
-            <a:off x="6604001" y="2918818"/>
+            <a:off x="6604001" y="2579773"/>
             <a:ext cx="4792980" cy="159940"/>
           </a:xfrm>
           <a:prstGeom prst="rect">
@@ -34432,7 +35993,7 @@
         </p:nvSpPr>
         <p:spPr>
           <a:xfrm>
-            <a:off x="6604001" y="3142257"/>
+            <a:off x="6604001" y="2803212"/>
             <a:ext cx="4792980" cy="152400"/>
           </a:xfrm>
           <a:prstGeom prst="rect">
@@ -34476,7 +36037,7 @@
         </p:nvSpPr>
         <p:spPr>
           <a:xfrm>
-            <a:off x="6604001" y="3320057"/>
+            <a:off x="6604001" y="2981012"/>
             <a:ext cx="4792980" cy="152400"/>
           </a:xfrm>
           <a:prstGeom prst="rect">
@@ -34523,7 +36084,7 @@
         </p:nvSpPr>
         <p:spPr>
           <a:xfrm>
-            <a:off x="6604001" y="3497857"/>
+            <a:off x="6604001" y="3158812"/>
             <a:ext cx="4792980" cy="152400"/>
           </a:xfrm>
           <a:prstGeom prst="rect">
@@ -34570,7 +36131,7 @@
         </p:nvSpPr>
         <p:spPr>
           <a:xfrm>
-            <a:off x="6451600" y="4132857"/>
+            <a:off x="6451600" y="3793812"/>
             <a:ext cx="5003800" cy="1322784"/>
           </a:xfrm>
           <a:prstGeom prst="roundRect">
@@ -34606,7 +36167,7 @@
         </p:nvSpPr>
         <p:spPr>
           <a:xfrm>
-            <a:off x="6616700" y="4272558"/>
+            <a:off x="6616700" y="3933513"/>
             <a:ext cx="4767072" cy="142081"/>
           </a:xfrm>
           <a:prstGeom prst="rect">
@@ -34653,7 +36214,7 @@
         </p:nvSpPr>
         <p:spPr>
           <a:xfrm>
-            <a:off x="6616700" y="4490840"/>
+            <a:off x="6616700" y="4151795"/>
             <a:ext cx="4767072" cy="142081"/>
           </a:xfrm>
           <a:prstGeom prst="rect">
@@ -34700,7 +36261,7 @@
         </p:nvSpPr>
         <p:spPr>
           <a:xfrm>
-            <a:off x="6616700" y="4709120"/>
+            <a:off x="6616700" y="4370075"/>
             <a:ext cx="4673600" cy="606821"/>
           </a:xfrm>
           <a:prstGeom prst="roundRect">
@@ -34732,7 +36293,7 @@
         </p:nvSpPr>
         <p:spPr>
           <a:xfrm>
-            <a:off x="6718300" y="4785321"/>
+            <a:off x="6718300" y="4446276"/>
             <a:ext cx="4559808" cy="142081"/>
           </a:xfrm>
           <a:prstGeom prst="rect">
@@ -34776,7 +36337,7 @@
         </p:nvSpPr>
         <p:spPr>
           <a:xfrm>
-            <a:off x="6718300" y="4965502"/>
+            <a:off x="6718300" y="4626457"/>
             <a:ext cx="4559808" cy="124420"/>
           </a:xfrm>
           <a:prstGeom prst="rect">
@@ -34823,7 +36384,7 @@
         </p:nvSpPr>
         <p:spPr>
           <a:xfrm>
-            <a:off x="6718300" y="5115322"/>
+            <a:off x="6718300" y="4776277"/>
             <a:ext cx="4559808" cy="124420"/>
           </a:xfrm>
           <a:prstGeom prst="rect">
@@ -34870,7 +36431,7 @@
         </p:nvSpPr>
         <p:spPr>
           <a:xfrm>
-            <a:off x="508000" y="5957691"/>
+            <a:off x="508000" y="5618646"/>
             <a:ext cx="11176000" cy="413940"/>
           </a:xfrm>
           <a:prstGeom prst="roundRect">
@@ -34902,7 +36463,7 @@
         </p:nvSpPr>
         <p:spPr>
           <a:xfrm>
-            <a:off x="702310" y="6015633"/>
+            <a:off x="702310" y="5676588"/>
             <a:ext cx="11010900" cy="159940"/>
           </a:xfrm>
           <a:prstGeom prst="rect">
@@ -35047,7 +36608,7 @@
         </p:nvSpPr>
         <p:spPr>
           <a:xfrm>
-            <a:off x="522334" y="1173757"/>
+            <a:off x="522334" y="834712"/>
             <a:ext cx="45719" cy="4510666"/>
           </a:xfrm>
           <a:prstGeom prst="rect">
@@ -35110,7 +36671,7 @@
         </p:nvSpPr>
         <p:spPr>
           <a:xfrm>
-            <a:off x="6194453" y="1158684"/>
+            <a:off x="6194453" y="819639"/>
             <a:ext cx="45719" cy="4530725"/>
           </a:xfrm>
           <a:prstGeom prst="rect">
@@ -35156,6 +36717,230 @@
               <a:latin typeface="Source Sans Pro" panose="020B0503030403020204" pitchFamily="34" charset="0"/>
               <a:ea typeface="Source Sans Pro" panose="020B0503030403020204" pitchFamily="34" charset="0"/>
             </a:endParaRPr>
+          </a:p>
+        </p:txBody>
+      </p:sp>
+      <p:sp>
+        <p:nvSpPr>
+          <p:cNvPr id="4" name="TextBox 3">
+            <a:extLst>
+              <a:ext uri="{FF2B5EF4-FFF2-40B4-BE49-F238E27FC236}">
+                <a16:creationId xmlns:a16="http://schemas.microsoft.com/office/drawing/2014/main" id="{28FDC4BE-41B0-F06D-A5E1-A1E86E18442B}"/>
+              </a:ext>
+            </a:extLst>
+          </p:cNvPr>
+          <p:cNvSpPr txBox="1"/>
+          <p:nvPr/>
+        </p:nvSpPr>
+        <p:spPr>
+          <a:xfrm>
+            <a:off x="11776719" y="6400800"/>
+            <a:ext cx="304892" cy="369332"/>
+          </a:xfrm>
+          <a:prstGeom prst="rect">
+            <a:avLst/>
+          </a:prstGeom>
+          <a:noFill/>
+        </p:spPr>
+        <p:txBody>
+          <a:bodyPr wrap="none" rtlCol="0">
+            <a:spAutoFit/>
+          </a:bodyPr>
+          <a:lstStyle/>
+          <a:p>
+            <a:r>
+              <a:rPr lang="en-US" dirty="0">
+                <a:latin typeface="Tenorite" pitchFamily="2" charset="0"/>
+              </a:rPr>
+              <a:t>5</a:t>
+            </a:r>
+          </a:p>
+        </p:txBody>
+      </p:sp>
+      <p:sp>
+        <p:nvSpPr>
+          <p:cNvPr id="42" name="Shape 54">
+            <a:extLst>
+              <a:ext uri="{FF2B5EF4-FFF2-40B4-BE49-F238E27FC236}">
+                <a16:creationId xmlns:a16="http://schemas.microsoft.com/office/drawing/2014/main" id="{3A1016F3-A728-F871-753B-E9B5A33F6BE7}"/>
+              </a:ext>
+            </a:extLst>
+          </p:cNvPr>
+          <p:cNvSpPr/>
+          <p:nvPr/>
+        </p:nvSpPr>
+        <p:spPr>
+          <a:xfrm>
+            <a:off x="406400" y="6172295"/>
+            <a:ext cx="11379200" cy="0"/>
+          </a:xfrm>
+          <a:prstGeom prst="line">
+            <a:avLst/>
+          </a:prstGeom>
+          <a:noFill/>
+          <a:ln w="9525">
+            <a:solidFill>
+              <a:srgbClr val="E2E8F0"/>
+            </a:solidFill>
+            <a:prstDash val="solid"/>
+          </a:ln>
+        </p:spPr>
+        <p:txBody>
+          <a:bodyPr/>
+          <a:lstStyle/>
+          <a:p>
+            <a:endParaRPr lang="en-US" sz="2800">
+              <a:latin typeface="Source Sans Pro" panose="020B0503030403020204" pitchFamily="34" charset="0"/>
+              <a:ea typeface="Source Sans Pro" panose="020B0503030403020204" pitchFamily="34" charset="0"/>
+            </a:endParaRPr>
+          </a:p>
+        </p:txBody>
+      </p:sp>
+      <p:sp>
+        <p:nvSpPr>
+          <p:cNvPr id="47" name="TextBox 46">
+            <a:extLst>
+              <a:ext uri="{FF2B5EF4-FFF2-40B4-BE49-F238E27FC236}">
+                <a16:creationId xmlns:a16="http://schemas.microsoft.com/office/drawing/2014/main" id="{D77A9BFF-345F-8C1F-5A29-91BB45584FC5}"/>
+              </a:ext>
+            </a:extLst>
+          </p:cNvPr>
+          <p:cNvSpPr txBox="1"/>
+          <p:nvPr/>
+        </p:nvSpPr>
+        <p:spPr>
+          <a:xfrm>
+            <a:off x="6194453" y="6215866"/>
+            <a:ext cx="5591147" cy="430887"/>
+          </a:xfrm>
+          <a:prstGeom prst="rect">
+            <a:avLst/>
+          </a:prstGeom>
+          <a:noFill/>
+        </p:spPr>
+        <p:txBody>
+          <a:bodyPr wrap="square" rtlCol="0">
+            <a:spAutoFit/>
+          </a:bodyPr>
+          <a:lstStyle/>
+          <a:p>
+            <a:r>
+              <a:rPr lang="en-GB" sz="1100" i="1" dirty="0">
+                <a:solidFill>
+                  <a:schemeClr val="bg2">
+                    <a:lumMod val="50000"/>
+                  </a:schemeClr>
+                </a:solidFill>
+                <a:latin typeface="Source Sans Pro" panose="020B0503030403020204" pitchFamily="34" charset="0"/>
+                <a:ea typeface="Source Sans Pro" panose="020B0503030403020204" pitchFamily="34" charset="0"/>
+              </a:rPr>
+              <a:t>"CBR-RAG: Case-Based Reasoning for Retrieval Augmented Generation in LLMs for Legal Question Answering," </a:t>
+            </a:r>
+            <a:r>
+              <a:rPr lang="en-GB" sz="1100" i="1" dirty="0">
+                <a:solidFill>
+                  <a:schemeClr val="bg2">
+                    <a:lumMod val="50000"/>
+                  </a:schemeClr>
+                </a:solidFill>
+                <a:latin typeface="Source Sans Pro" panose="020B0503030403020204" pitchFamily="34" charset="0"/>
+                <a:ea typeface="Source Sans Pro" panose="020B0503030403020204" pitchFamily="34" charset="0"/>
+                <a:hlinkClick r:id="rId3">
+                  <a:extLst>
+                    <a:ext uri="{A12FA001-AC4F-418D-AE19-62706E023703}">
+                      <ahyp:hlinkClr xmlns:ahyp="http://schemas.microsoft.com/office/drawing/2018/hyperlinkcolor" val="tx"/>
+                    </a:ext>
+                  </a:extLst>
+                </a:hlinkClick>
+              </a:rPr>
+              <a:t>https://arxiv.org/abs/2404.04302</a:t>
+            </a:r>
+            <a:r>
+              <a:rPr lang="en-SG" sz="1100" i="1" dirty="0">
+                <a:solidFill>
+                  <a:schemeClr val="bg2">
+                    <a:lumMod val="50000"/>
+                  </a:schemeClr>
+                </a:solidFill>
+                <a:latin typeface="Source Sans Pro" panose="020B0503030403020204" pitchFamily="34" charset="0"/>
+                <a:ea typeface="Source Sans Pro" panose="020B0503030403020204" pitchFamily="34" charset="0"/>
+              </a:rPr>
+              <a:t> </a:t>
+            </a:r>
+          </a:p>
+        </p:txBody>
+      </p:sp>
+      <p:sp>
+        <p:nvSpPr>
+          <p:cNvPr id="48" name="TextBox 47">
+            <a:extLst>
+              <a:ext uri="{FF2B5EF4-FFF2-40B4-BE49-F238E27FC236}">
+                <a16:creationId xmlns:a16="http://schemas.microsoft.com/office/drawing/2014/main" id="{0CD54BC6-B148-248F-F05B-61DA7D9F2A5B}"/>
+              </a:ext>
+            </a:extLst>
+          </p:cNvPr>
+          <p:cNvSpPr txBox="1"/>
+          <p:nvPr/>
+        </p:nvSpPr>
+        <p:spPr>
+          <a:xfrm>
+            <a:off x="487631" y="6215866"/>
+            <a:ext cx="5481370" cy="430887"/>
+          </a:xfrm>
+          <a:prstGeom prst="rect">
+            <a:avLst/>
+          </a:prstGeom>
+          <a:noFill/>
+        </p:spPr>
+        <p:txBody>
+          <a:bodyPr wrap="square" rtlCol="0">
+            <a:spAutoFit/>
+          </a:bodyPr>
+          <a:lstStyle/>
+          <a:p>
+            <a:r>
+              <a:rPr lang="en-GB" sz="1100" i="1" dirty="0">
+                <a:solidFill>
+                  <a:schemeClr val="bg2">
+                    <a:lumMod val="50000"/>
+                  </a:schemeClr>
+                </a:solidFill>
+                <a:latin typeface="Source Sans Pro" panose="020B0503030403020204" pitchFamily="34" charset="0"/>
+                <a:ea typeface="Source Sans Pro" panose="020B0503030403020204" pitchFamily="34" charset="0"/>
+              </a:rPr>
+              <a:t>“Primus: A Pioneering Collection of Open-Source Datasets for Cybersecurity LLM Training,” </a:t>
+            </a:r>
+            <a:r>
+              <a:rPr lang="en-GB" sz="1100" i="1" dirty="0">
+                <a:solidFill>
+                  <a:schemeClr val="bg2">
+                    <a:lumMod val="50000"/>
+                  </a:schemeClr>
+                </a:solidFill>
+                <a:latin typeface="Source Sans Pro" panose="020B0503030403020204" pitchFamily="34" charset="0"/>
+                <a:ea typeface="Source Sans Pro" panose="020B0503030403020204" pitchFamily="34" charset="0"/>
+                <a:hlinkClick r:id="rId4">
+                  <a:extLst>
+                    <a:ext uri="{A12FA001-AC4F-418D-AE19-62706E023703}">
+                      <ahyp:hlinkClr xmlns:ahyp="http://schemas.microsoft.com/office/drawing/2018/hyperlinkcolor" val="tx"/>
+                    </a:ext>
+                  </a:extLst>
+                </a:hlinkClick>
+              </a:rPr>
+              <a:t>https://arxiv.org/abs/2502.11191</a:t>
+            </a:r>
+            <a:r>
+              <a:rPr lang="en-SG" sz="800" dirty="0">
+                <a:solidFill>
+                  <a:schemeClr val="bg2">
+                    <a:lumMod val="50000"/>
+                  </a:schemeClr>
+                </a:solidFill>
+                <a:latin typeface="Source Sans Pro" panose="020B0503030403020204" pitchFamily="34" charset="0"/>
+                <a:ea typeface="Source Sans Pro" panose="020B0503030403020204" pitchFamily="34" charset="0"/>
+              </a:rPr>
+              <a:t> </a:t>
+            </a:r>
           </a:p>
         </p:txBody>
       </p:sp>
@@ -37442,6 +39227,43 @@
               <a:ea typeface="Source Sans Pro" panose="020B0503030403020204" pitchFamily="34" charset="0"/>
               <a:cs typeface="Segoe UI" panose="020B0502040204020203" pitchFamily="34" charset="0"/>
             </a:endParaRPr>
+          </a:p>
+        </p:txBody>
+      </p:sp>
+      <p:sp>
+        <p:nvSpPr>
+          <p:cNvPr id="55" name="TextBox 54">
+            <a:extLst>
+              <a:ext uri="{FF2B5EF4-FFF2-40B4-BE49-F238E27FC236}">
+                <a16:creationId xmlns:a16="http://schemas.microsoft.com/office/drawing/2014/main" id="{4F0C013B-9DD3-7AFE-C0EF-7551E876F0DC}"/>
+              </a:ext>
+            </a:extLst>
+          </p:cNvPr>
+          <p:cNvSpPr txBox="1"/>
+          <p:nvPr/>
+        </p:nvSpPr>
+        <p:spPr>
+          <a:xfrm>
+            <a:off x="11776719" y="6400800"/>
+            <a:ext cx="304892" cy="369332"/>
+          </a:xfrm>
+          <a:prstGeom prst="rect">
+            <a:avLst/>
+          </a:prstGeom>
+          <a:noFill/>
+        </p:spPr>
+        <p:txBody>
+          <a:bodyPr wrap="none" rtlCol="0">
+            <a:spAutoFit/>
+          </a:bodyPr>
+          <a:lstStyle/>
+          <a:p>
+            <a:r>
+              <a:rPr lang="en-US" dirty="0">
+                <a:latin typeface="Tenorite" pitchFamily="2" charset="0"/>
+              </a:rPr>
+              <a:t>6</a:t>
+            </a:r>
           </a:p>
         </p:txBody>
       </p:sp>
@@ -39814,6 +41636,195 @@
               <a:latin typeface="Source Sans Pro" panose="020B0503030403020204" pitchFamily="34" charset="0"/>
               <a:ea typeface="Source Sans Pro" panose="020B0503030403020204" pitchFamily="34" charset="0"/>
             </a:endParaRPr>
+          </a:p>
+        </p:txBody>
+      </p:sp>
+      <p:sp>
+        <p:nvSpPr>
+          <p:cNvPr id="3" name="TextBox 2">
+            <a:extLst>
+              <a:ext uri="{FF2B5EF4-FFF2-40B4-BE49-F238E27FC236}">
+                <a16:creationId xmlns:a16="http://schemas.microsoft.com/office/drawing/2014/main" id="{AFCA0CF2-6B9B-C7E9-17F3-44E30D7922CF}"/>
+              </a:ext>
+            </a:extLst>
+          </p:cNvPr>
+          <p:cNvSpPr txBox="1"/>
+          <p:nvPr/>
+        </p:nvSpPr>
+        <p:spPr>
+          <a:xfrm>
+            <a:off x="11776719" y="6400800"/>
+            <a:ext cx="304892" cy="369332"/>
+          </a:xfrm>
+          <a:prstGeom prst="rect">
+            <a:avLst/>
+          </a:prstGeom>
+          <a:noFill/>
+        </p:spPr>
+        <p:txBody>
+          <a:bodyPr wrap="none" rtlCol="0">
+            <a:spAutoFit/>
+          </a:bodyPr>
+          <a:lstStyle/>
+          <a:p>
+            <a:r>
+              <a:rPr lang="en-US" dirty="0">
+                <a:latin typeface="Tenorite" pitchFamily="2" charset="0"/>
+              </a:rPr>
+              <a:t>7</a:t>
+            </a:r>
+          </a:p>
+        </p:txBody>
+      </p:sp>
+      <p:sp>
+        <p:nvSpPr>
+          <p:cNvPr id="5" name="TextBox 4">
+            <a:extLst>
+              <a:ext uri="{FF2B5EF4-FFF2-40B4-BE49-F238E27FC236}">
+                <a16:creationId xmlns:a16="http://schemas.microsoft.com/office/drawing/2014/main" id="{6CCFF63B-D84A-89DA-3CD1-5E43FCAAAE22}"/>
+              </a:ext>
+            </a:extLst>
+          </p:cNvPr>
+          <p:cNvSpPr txBox="1"/>
+          <p:nvPr/>
+        </p:nvSpPr>
+        <p:spPr>
+          <a:xfrm>
+            <a:off x="614025" y="6339245"/>
+            <a:ext cx="10815974" cy="430887"/>
+          </a:xfrm>
+          <a:prstGeom prst="rect">
+            <a:avLst/>
+          </a:prstGeom>
+          <a:noFill/>
+        </p:spPr>
+        <p:txBody>
+          <a:bodyPr wrap="square">
+            <a:spAutoFit/>
+          </a:bodyPr>
+          <a:lstStyle/>
+          <a:p>
+            <a:r>
+              <a:rPr lang="en-US" sz="1100" i="1" dirty="0">
+                <a:solidFill>
+                  <a:schemeClr val="bg2">
+                    <a:lumMod val="50000"/>
+                  </a:schemeClr>
+                </a:solidFill>
+                <a:latin typeface="Source Sans Pro" panose="020B0503030403020204" pitchFamily="34" charset="0"/>
+                <a:ea typeface="Source Sans Pro" panose="020B0503030403020204" pitchFamily="34" charset="0"/>
+              </a:rPr>
+              <a:t>T. Dettmers, A. Pagnoni, A. Holtzman, and L. Zettlemoyer, "QLoRA: Efficient Finetuning of Quantized LLMs," </a:t>
+            </a:r>
+            <a:r>
+              <a:rPr lang="en-US" sz="1100" i="1" dirty="0" err="1">
+                <a:solidFill>
+                  <a:schemeClr val="bg2">
+                    <a:lumMod val="50000"/>
+                  </a:schemeClr>
+                </a:solidFill>
+                <a:latin typeface="Source Sans Pro" panose="020B0503030403020204" pitchFamily="34" charset="0"/>
+                <a:ea typeface="Source Sans Pro" panose="020B0503030403020204" pitchFamily="34" charset="0"/>
+              </a:rPr>
+              <a:t>arXiv</a:t>
+            </a:r>
+            <a:r>
+              <a:rPr lang="en-US" sz="1100" i="1" dirty="0">
+                <a:solidFill>
+                  <a:schemeClr val="bg2">
+                    <a:lumMod val="50000"/>
+                  </a:schemeClr>
+                </a:solidFill>
+                <a:latin typeface="Source Sans Pro" panose="020B0503030403020204" pitchFamily="34" charset="0"/>
+                <a:ea typeface="Source Sans Pro" panose="020B0503030403020204" pitchFamily="34" charset="0"/>
+              </a:rPr>
+              <a:t> preprint arXiv:2305.14314, 2023. [Online]. Available: </a:t>
+            </a:r>
+            <a:r>
+              <a:rPr lang="en-US" sz="1100" i="1" dirty="0">
+                <a:solidFill>
+                  <a:schemeClr val="bg2">
+                    <a:lumMod val="50000"/>
+                  </a:schemeClr>
+                </a:solidFill>
+                <a:latin typeface="Source Sans Pro" panose="020B0503030403020204" pitchFamily="34" charset="0"/>
+                <a:ea typeface="Source Sans Pro" panose="020B0503030403020204" pitchFamily="34" charset="0"/>
+                <a:hlinkClick r:id="rId4"/>
+              </a:rPr>
+              <a:t>https://arxiv.</a:t>
+            </a:r>
+            <a:r>
+              <a:rPr lang="en-US" sz="1100" i="1" dirty="0">
+                <a:solidFill>
+                  <a:schemeClr val="bg2">
+                    <a:lumMod val="50000"/>
+                  </a:schemeClr>
+                </a:solidFill>
+                <a:latin typeface="Source Sans Pro" panose="020B0503030403020204" pitchFamily="34" charset="0"/>
+                <a:ea typeface="Source Sans Pro" panose="020B0503030403020204" pitchFamily="34" charset="0"/>
+                <a:cs typeface="Arial" pitchFamily="34" charset="-120"/>
+                <a:hlinkClick r:id="rId4"/>
+              </a:rPr>
+              <a:t>org</a:t>
+            </a:r>
+            <a:r>
+              <a:rPr lang="en-US" sz="1100" i="1" dirty="0">
+                <a:solidFill>
+                  <a:schemeClr val="bg2">
+                    <a:lumMod val="50000"/>
+                  </a:schemeClr>
+                </a:solidFill>
+                <a:latin typeface="Source Sans Pro" panose="020B0503030403020204" pitchFamily="34" charset="0"/>
+                <a:ea typeface="Source Sans Pro" panose="020B0503030403020204" pitchFamily="34" charset="0"/>
+                <a:hlinkClick r:id="rId4"/>
+              </a:rPr>
+              <a:t>/abs/2305.14314</a:t>
+            </a:r>
+            <a:endParaRPr lang="en-US" sz="1100" i="1" dirty="0">
+              <a:solidFill>
+                <a:schemeClr val="bg2">
+                  <a:lumMod val="50000"/>
+                </a:schemeClr>
+              </a:solidFill>
+              <a:latin typeface="Source Sans Pro" panose="020B0503030403020204" pitchFamily="34" charset="0"/>
+              <a:ea typeface="Source Sans Pro" panose="020B0503030403020204" pitchFamily="34" charset="0"/>
+            </a:endParaRPr>
+          </a:p>
+        </p:txBody>
+      </p:sp>
+      <p:sp>
+        <p:nvSpPr>
+          <p:cNvPr id="6" name="Shape 60">
+            <a:extLst>
+              <a:ext uri="{FF2B5EF4-FFF2-40B4-BE49-F238E27FC236}">
+                <a16:creationId xmlns:a16="http://schemas.microsoft.com/office/drawing/2014/main" id="{56B6E59B-133D-FAB6-AA64-D680D319D723}"/>
+              </a:ext>
+            </a:extLst>
+          </p:cNvPr>
+          <p:cNvSpPr/>
+          <p:nvPr/>
+        </p:nvSpPr>
+        <p:spPr>
+          <a:xfrm>
+            <a:off x="592922" y="6352635"/>
+            <a:ext cx="11379200" cy="0"/>
+          </a:xfrm>
+          <a:prstGeom prst="line">
+            <a:avLst/>
+          </a:prstGeom>
+          <a:noFill/>
+          <a:ln w="9525">
+            <a:solidFill>
+              <a:srgbClr val="E2E8F0"/>
+            </a:solidFill>
+            <a:prstDash val="solid"/>
+          </a:ln>
+        </p:spPr>
+        <p:txBody>
+          <a:bodyPr/>
+          <a:lstStyle/>
+          <a:p>
+            <a:endParaRPr lang="en-US" sz="2400"/>
           </a:p>
         </p:txBody>
       </p:sp>

</xml_diff>